<commit_message>
added explanation of why we chose Blakleys method for modular mutliplication in our algorithm
</commit_message>
<xml_diff>
--- a/TermProject/Microarchitecture_presentation.pptx
+++ b/TermProject/Microarchitecture_presentation.pptx
@@ -4,6 +4,9 @@
   <p:sldMasterIdLst>
     <p:sldMasterId id="2147483648" r:id="rId1"/>
   </p:sldMasterIdLst>
+  <p:notesMasterIdLst>
+    <p:notesMasterId r:id="rId7"/>
+  </p:notesMasterIdLst>
   <p:sldIdLst>
     <p:sldId id="256" r:id="rId2"/>
     <p:sldId id="257" r:id="rId3"/>
@@ -109,6 +112,1152 @@
     </a:lvl9pPr>
   </p:defaultTextStyle>
 </p:presentation>
+</file>
+
+<file path=ppt/ink/ink1.xml><?xml version="1.0" encoding="utf-8"?>
+<inkml:ink xmlns:inkml="http://www.w3.org/2003/InkML">
+  <inkml:definitions>
+    <inkml:context xml:id="ctx0">
+      <inkml:inkSource xml:id="inkSrc0">
+        <inkml:traceFormat>
+          <inkml:channel name="X" type="integer" min="-2.14748E9" max="2.14748E9" units="cm"/>
+          <inkml:channel name="Y" type="integer" min="-2.14748E9" max="2.14748E9" units="cm"/>
+          <inkml:channel name="F" type="integer" max="32767" units="dev"/>
+        </inkml:traceFormat>
+        <inkml:channelProperties>
+          <inkml:channelProperty channel="X" name="resolution" value="1000" units="1/cm"/>
+          <inkml:channelProperty channel="Y" name="resolution" value="1000" units="1/cm"/>
+          <inkml:channelProperty channel="F" name="resolution" value="0" units="1/dev"/>
+        </inkml:channelProperties>
+      </inkml:inkSource>
+      <inkml:timestamp xml:id="ts0" timeString="2025-09-26T10:15:13.067"/>
+    </inkml:context>
+    <inkml:brush xml:id="br0">
+      <inkml:brushProperty name="width" value="0.035" units="cm"/>
+      <inkml:brushProperty name="height" value="0.035" units="cm"/>
+      <inkml:brushProperty name="color" value="#E71224"/>
+    </inkml:brush>
+  </inkml:definitions>
+  <inkml:trace contextRef="#ctx0" brushRef="#br0">1392 0 24245,'-1392'0'0</inkml:trace>
+</inkml:ink>
+</file>
+
+<file path=ppt/ink/ink2.xml><?xml version="1.0" encoding="utf-8"?>
+<inkml:ink xmlns:inkml="http://www.w3.org/2003/InkML">
+  <inkml:definitions>
+    <inkml:context xml:id="ctx0">
+      <inkml:inkSource xml:id="inkSrc0">
+        <inkml:traceFormat>
+          <inkml:channel name="X" type="integer" min="-2.14748E9" max="2.14748E9" units="cm"/>
+          <inkml:channel name="Y" type="integer" min="-2.14748E9" max="2.14748E9" units="cm"/>
+          <inkml:channel name="F" type="integer" max="32767" units="dev"/>
+        </inkml:traceFormat>
+        <inkml:channelProperties>
+          <inkml:channelProperty channel="X" name="resolution" value="1000" units="1/cm"/>
+          <inkml:channelProperty channel="Y" name="resolution" value="1000" units="1/cm"/>
+          <inkml:channelProperty channel="F" name="resolution" value="0" units="1/dev"/>
+        </inkml:channelProperties>
+      </inkml:inkSource>
+      <inkml:timestamp xml:id="ts0" timeString="2025-09-26T10:15:18.680"/>
+    </inkml:context>
+    <inkml:brush xml:id="br0">
+      <inkml:brushProperty name="width" value="0.035" units="cm"/>
+      <inkml:brushProperty name="height" value="0.035" units="cm"/>
+      <inkml:brushProperty name="color" value="#E71224"/>
+    </inkml:brush>
+  </inkml:definitions>
+  <inkml:trace contextRef="#ctx0" brushRef="#br0">107 0 22267,'0'2965'0</inkml:trace>
+</inkml:ink>
+</file>
+
+<file path=ppt/ink/ink3.xml><?xml version="1.0" encoding="utf-8"?>
+<inkml:ink xmlns:inkml="http://www.w3.org/2003/InkML">
+  <inkml:definitions>
+    <inkml:context xml:id="ctx0">
+      <inkml:inkSource xml:id="inkSrc0">
+        <inkml:traceFormat>
+          <inkml:channel name="X" type="integer" min="-2.14748E9" max="2.14748E9" units="cm"/>
+          <inkml:channel name="Y" type="integer" min="-2.14748E9" max="2.14748E9" units="cm"/>
+          <inkml:channel name="F" type="integer" max="32767" units="dev"/>
+        </inkml:traceFormat>
+        <inkml:channelProperties>
+          <inkml:channelProperty channel="X" name="resolution" value="1000" units="1/cm"/>
+          <inkml:channelProperty channel="Y" name="resolution" value="1000" units="1/cm"/>
+          <inkml:channelProperty channel="F" name="resolution" value="0" units="1/dev"/>
+        </inkml:channelProperties>
+      </inkml:inkSource>
+      <inkml:timestamp xml:id="ts0" timeString="2025-09-26T10:15:24.417"/>
+    </inkml:context>
+    <inkml:brush xml:id="br0">
+      <inkml:brushProperty name="width" value="0.035" units="cm"/>
+      <inkml:brushProperty name="height" value="0.035" units="cm"/>
+      <inkml:brushProperty name="color" value="#E71224"/>
+    </inkml:brush>
+  </inkml:definitions>
+  <inkml:trace contextRef="#ctx0" brushRef="#br0">1 0 21389,'1450'0'0</inkml:trace>
+</inkml:ink>
+</file>
+
+<file path=ppt/ink/ink4.xml><?xml version="1.0" encoding="utf-8"?>
+<inkml:ink xmlns:inkml="http://www.w3.org/2003/InkML">
+  <inkml:definitions>
+    <inkml:context xml:id="ctx0">
+      <inkml:inkSource xml:id="inkSrc0">
+        <inkml:traceFormat>
+          <inkml:channel name="X" type="integer" min="-2.14748E9" max="2.14748E9" units="cm"/>
+          <inkml:channel name="Y" type="integer" min="-2.14748E9" max="2.14748E9" units="cm"/>
+          <inkml:channel name="F" type="integer" max="32767" units="dev"/>
+        </inkml:traceFormat>
+        <inkml:channelProperties>
+          <inkml:channelProperty channel="X" name="resolution" value="1000" units="1/cm"/>
+          <inkml:channelProperty channel="Y" name="resolution" value="1000" units="1/cm"/>
+          <inkml:channelProperty channel="F" name="resolution" value="0" units="1/dev"/>
+        </inkml:channelProperties>
+      </inkml:inkSource>
+      <inkml:timestamp xml:id="ts0" timeString="2025-09-26T10:15:36.589"/>
+    </inkml:context>
+    <inkml:brush xml:id="br0">
+      <inkml:brushProperty name="width" value="0.035" units="cm"/>
+      <inkml:brushProperty name="height" value="0.035" units="cm"/>
+      <inkml:brushProperty name="color" value="#E71224"/>
+    </inkml:brush>
+  </inkml:definitions>
+  <inkml:trace contextRef="#ctx0" brushRef="#br0">144 6 24575,'-3'0'0,"-3"0"0,-3 0 0,-3 0 0,-2 0 0,0 0 0,-2 0 0,0 0 0,1 0 0,-1 0 0,3-2 0,4-1-8191</inkml:trace>
+</inkml:ink>
+</file>
+
+<file path=ppt/ink/ink5.xml><?xml version="1.0" encoding="utf-8"?>
+<inkml:ink xmlns:inkml="http://www.w3.org/2003/InkML">
+  <inkml:definitions>
+    <inkml:context xml:id="ctx0">
+      <inkml:inkSource xml:id="inkSrc0">
+        <inkml:traceFormat>
+          <inkml:channel name="X" type="integer" min="-2.14748E9" max="2.14748E9" units="cm"/>
+          <inkml:channel name="Y" type="integer" min="-2.14748E9" max="2.14748E9" units="cm"/>
+          <inkml:channel name="F" type="integer" max="32767" units="dev"/>
+        </inkml:traceFormat>
+        <inkml:channelProperties>
+          <inkml:channelProperty channel="X" name="resolution" value="1000" units="1/cm"/>
+          <inkml:channelProperty channel="Y" name="resolution" value="1000" units="1/cm"/>
+          <inkml:channelProperty channel="F" name="resolution" value="0" units="1/dev"/>
+        </inkml:channelProperties>
+      </inkml:inkSource>
+      <inkml:timestamp xml:id="ts0" timeString="2025-09-26T10:15:40.002"/>
+    </inkml:context>
+    <inkml:brush xml:id="br0">
+      <inkml:brushProperty name="width" value="0.035" units="cm"/>
+      <inkml:brushProperty name="height" value="0.035" units="cm"/>
+      <inkml:brushProperty name="color" value="#E71224"/>
+    </inkml:brush>
+  </inkml:definitions>
+  <inkml:trace contextRef="#ctx0" brushRef="#br0">20 1 24176,'0'1165'0</inkml:trace>
+</inkml:ink>
+</file>
+
+<file path=ppt/ink/ink6.xml><?xml version="1.0" encoding="utf-8"?>
+<inkml:ink xmlns:inkml="http://www.w3.org/2003/InkML">
+  <inkml:definitions>
+    <inkml:context xml:id="ctx0">
+      <inkml:inkSource xml:id="inkSrc0">
+        <inkml:traceFormat>
+          <inkml:channel name="X" type="integer" min="-2.14748E9" max="2.14748E9" units="cm"/>
+          <inkml:channel name="Y" type="integer" min="-2.14748E9" max="2.14748E9" units="cm"/>
+          <inkml:channel name="F" type="integer" max="32767" units="dev"/>
+        </inkml:traceFormat>
+        <inkml:channelProperties>
+          <inkml:channelProperty channel="X" name="resolution" value="1000" units="1/cm"/>
+          <inkml:channelProperty channel="Y" name="resolution" value="1000" units="1/cm"/>
+          <inkml:channelProperty channel="F" name="resolution" value="0" units="1/dev"/>
+        </inkml:channelProperties>
+      </inkml:inkSource>
+      <inkml:timestamp xml:id="ts0" timeString="2025-09-26T10:15:46.218"/>
+    </inkml:context>
+    <inkml:brush xml:id="br0">
+      <inkml:brushProperty name="width" value="0.035" units="cm"/>
+      <inkml:brushProperty name="height" value="0.035" units="cm"/>
+      <inkml:brushProperty name="color" value="#E71224"/>
+    </inkml:brush>
+  </inkml:definitions>
+  <inkml:trace contextRef="#ctx0" brushRef="#br0">0 24 24575,'223'0'0,"-218"0"0,-3 0 0,0 0 0,0 0 0,0 0 0,0 0 0,0 0 0,0 0 0,0 0 0,0-1 0,0 1 0,0-1 0,0 0 0,0 1 0,0-1 0,3-2 0,-5 3-37,0-1 0,1 1 1,-1 0-1,0-1 0,0 1 0,0-1 0,0 1 0,0 0 0,0-1 0,-1 1 0,1-1 0,0 1 1,0 0-1,0-1 0,0 1 0,0 0 0,0-1 0,-1 1 0,1-1 0,0 1 0,0 0 0,-1 0 1,1-1-1,0 1 0,0 0 0,-1-1 0,1 1 0,0 0 0,-1 0 0,1 0 0,0-1 0,-1 1 1,1 0-1,-1 0 0,1 0 0,-1 0 0,-10-6-6789</inkml:trace>
+</inkml:ink>
+</file>
+
+<file path=ppt/notesMasters/notesMaster1.xml><?xml version="1.0" encoding="utf-8"?>
+<p:notesMaster xmlns:a="http://schemas.openxmlformats.org/drawingml/2006/main" xmlns:r="http://schemas.openxmlformats.org/officeDocument/2006/relationships" xmlns:p="http://schemas.openxmlformats.org/presentationml/2006/main">
+  <p:cSld>
+    <p:bg>
+      <p:bgRef idx="1001">
+        <a:schemeClr val="bg1"/>
+      </p:bgRef>
+    </p:bg>
+    <p:spTree>
+      <p:nvGrpSpPr>
+        <p:cNvPr id="1" name=""/>
+        <p:cNvGrpSpPr/>
+        <p:nvPr/>
+      </p:nvGrpSpPr>
+      <p:grpSpPr>
+        <a:xfrm>
+          <a:off x="0" y="0"/>
+          <a:ext cx="0" cy="0"/>
+          <a:chOff x="0" y="0"/>
+          <a:chExt cx="0" cy="0"/>
+        </a:xfrm>
+      </p:grpSpPr>
+      <p:sp>
+        <p:nvSpPr>
+          <p:cNvPr id="2" name="Plassholder for topptekst 1"/>
+          <p:cNvSpPr>
+            <a:spLocks noGrp="1"/>
+          </p:cNvSpPr>
+          <p:nvPr>
+            <p:ph type="hdr" sz="quarter"/>
+          </p:nvPr>
+        </p:nvSpPr>
+        <p:spPr>
+          <a:xfrm>
+            <a:off x="0" y="0"/>
+            <a:ext cx="2971800" cy="458788"/>
+          </a:xfrm>
+          <a:prstGeom prst="rect">
+            <a:avLst/>
+          </a:prstGeom>
+        </p:spPr>
+        <p:txBody>
+          <a:bodyPr vert="horz" lIns="91440" tIns="45720" rIns="91440" bIns="45720" rtlCol="0"/>
+          <a:lstStyle>
+            <a:lvl1pPr algn="l">
+              <a:defRPr sz="1200"/>
+            </a:lvl1pPr>
+          </a:lstStyle>
+          <a:p>
+            <a:endParaRPr lang="nb-NO"/>
+          </a:p>
+        </p:txBody>
+      </p:sp>
+      <p:sp>
+        <p:nvSpPr>
+          <p:cNvPr id="3" name="Plassholder for dato 2"/>
+          <p:cNvSpPr>
+            <a:spLocks noGrp="1"/>
+          </p:cNvSpPr>
+          <p:nvPr>
+            <p:ph type="dt" idx="1"/>
+          </p:nvPr>
+        </p:nvSpPr>
+        <p:spPr>
+          <a:xfrm>
+            <a:off x="3884613" y="0"/>
+            <a:ext cx="2971800" cy="458788"/>
+          </a:xfrm>
+          <a:prstGeom prst="rect">
+            <a:avLst/>
+          </a:prstGeom>
+        </p:spPr>
+        <p:txBody>
+          <a:bodyPr vert="horz" lIns="91440" tIns="45720" rIns="91440" bIns="45720" rtlCol="0"/>
+          <a:lstStyle>
+            <a:lvl1pPr algn="r">
+              <a:defRPr sz="1200"/>
+            </a:lvl1pPr>
+          </a:lstStyle>
+          <a:p>
+            <a:fld id="{F4BB8A02-1B8F-4CA0-82C6-CD71F4E181AC}" type="datetimeFigureOut">
+              <a:rPr lang="nb-NO" smtClean="0"/>
+              <a:t>26.09.2025</a:t>
+            </a:fld>
+            <a:endParaRPr lang="nb-NO"/>
+          </a:p>
+        </p:txBody>
+      </p:sp>
+      <p:sp>
+        <p:nvSpPr>
+          <p:cNvPr id="4" name="Plassholder for lysbilde 3"/>
+          <p:cNvSpPr>
+            <a:spLocks noGrp="1" noRot="1" noChangeAspect="1"/>
+          </p:cNvSpPr>
+          <p:nvPr>
+            <p:ph type="sldImg" idx="2"/>
+          </p:nvPr>
+        </p:nvSpPr>
+        <p:spPr>
+          <a:xfrm>
+            <a:off x="685800" y="1143000"/>
+            <a:ext cx="5486400" cy="3086100"/>
+          </a:xfrm>
+          <a:prstGeom prst="rect">
+            <a:avLst/>
+          </a:prstGeom>
+          <a:noFill/>
+          <a:ln w="12700">
+            <a:solidFill>
+              <a:prstClr val="black"/>
+            </a:solidFill>
+          </a:ln>
+        </p:spPr>
+        <p:txBody>
+          <a:bodyPr vert="horz" lIns="91440" tIns="45720" rIns="91440" bIns="45720" rtlCol="0" anchor="ctr"/>
+          <a:lstStyle/>
+          <a:p>
+            <a:endParaRPr lang="nb-NO"/>
+          </a:p>
+        </p:txBody>
+      </p:sp>
+      <p:sp>
+        <p:nvSpPr>
+          <p:cNvPr id="5" name="Plassholder for notater 4"/>
+          <p:cNvSpPr>
+            <a:spLocks noGrp="1"/>
+          </p:cNvSpPr>
+          <p:nvPr>
+            <p:ph type="body" sz="quarter" idx="3"/>
+          </p:nvPr>
+        </p:nvSpPr>
+        <p:spPr>
+          <a:xfrm>
+            <a:off x="685800" y="4400550"/>
+            <a:ext cx="5486400" cy="3600450"/>
+          </a:xfrm>
+          <a:prstGeom prst="rect">
+            <a:avLst/>
+          </a:prstGeom>
+        </p:spPr>
+        <p:txBody>
+          <a:bodyPr vert="horz" lIns="91440" tIns="45720" rIns="91440" bIns="45720" rtlCol="0"/>
+          <a:lstStyle/>
+          <a:p>
+            <a:pPr lvl="0"/>
+            <a:r>
+              <a:rPr lang="nb-NO"/>
+              <a:t>Klikk for å redigere tekststiler i malen</a:t>
+            </a:r>
+          </a:p>
+          <a:p>
+            <a:pPr lvl="1"/>
+            <a:r>
+              <a:rPr lang="nb-NO"/>
+              <a:t>Andre nivå</a:t>
+            </a:r>
+          </a:p>
+          <a:p>
+            <a:pPr lvl="2"/>
+            <a:r>
+              <a:rPr lang="nb-NO"/>
+              <a:t>Tredje nivå</a:t>
+            </a:r>
+          </a:p>
+          <a:p>
+            <a:pPr lvl="3"/>
+            <a:r>
+              <a:rPr lang="nb-NO"/>
+              <a:t>Fjerde nivå</a:t>
+            </a:r>
+          </a:p>
+          <a:p>
+            <a:pPr lvl="4"/>
+            <a:r>
+              <a:rPr lang="nb-NO"/>
+              <a:t>Femte nivå</a:t>
+            </a:r>
+          </a:p>
+        </p:txBody>
+      </p:sp>
+      <p:sp>
+        <p:nvSpPr>
+          <p:cNvPr id="6" name="Plassholder for bunntekst 5"/>
+          <p:cNvSpPr>
+            <a:spLocks noGrp="1"/>
+          </p:cNvSpPr>
+          <p:nvPr>
+            <p:ph type="ftr" sz="quarter" idx="4"/>
+          </p:nvPr>
+        </p:nvSpPr>
+        <p:spPr>
+          <a:xfrm>
+            <a:off x="0" y="8685213"/>
+            <a:ext cx="2971800" cy="458787"/>
+          </a:xfrm>
+          <a:prstGeom prst="rect">
+            <a:avLst/>
+          </a:prstGeom>
+        </p:spPr>
+        <p:txBody>
+          <a:bodyPr vert="horz" lIns="91440" tIns="45720" rIns="91440" bIns="45720" rtlCol="0" anchor="b"/>
+          <a:lstStyle>
+            <a:lvl1pPr algn="l">
+              <a:defRPr sz="1200"/>
+            </a:lvl1pPr>
+          </a:lstStyle>
+          <a:p>
+            <a:endParaRPr lang="nb-NO"/>
+          </a:p>
+        </p:txBody>
+      </p:sp>
+      <p:sp>
+        <p:nvSpPr>
+          <p:cNvPr id="7" name="Plassholder for lysbildenummer 6"/>
+          <p:cNvSpPr>
+            <a:spLocks noGrp="1"/>
+          </p:cNvSpPr>
+          <p:nvPr>
+            <p:ph type="sldNum" sz="quarter" idx="5"/>
+          </p:nvPr>
+        </p:nvSpPr>
+        <p:spPr>
+          <a:xfrm>
+            <a:off x="3884613" y="8685213"/>
+            <a:ext cx="2971800" cy="458787"/>
+          </a:xfrm>
+          <a:prstGeom prst="rect">
+            <a:avLst/>
+          </a:prstGeom>
+        </p:spPr>
+        <p:txBody>
+          <a:bodyPr vert="horz" lIns="91440" tIns="45720" rIns="91440" bIns="45720" rtlCol="0" anchor="b"/>
+          <a:lstStyle>
+            <a:lvl1pPr algn="r">
+              <a:defRPr sz="1200"/>
+            </a:lvl1pPr>
+          </a:lstStyle>
+          <a:p>
+            <a:fld id="{216D7F6F-FEAF-4EC3-9D16-742F1314A19E}" type="slidenum">
+              <a:rPr lang="nb-NO" smtClean="0"/>
+              <a:t>‹#›</a:t>
+            </a:fld>
+            <a:endParaRPr lang="nb-NO"/>
+          </a:p>
+        </p:txBody>
+      </p:sp>
+    </p:spTree>
+    <p:extLst>
+      <p:ext uri="{BB962C8B-B14F-4D97-AF65-F5344CB8AC3E}">
+        <p14:creationId xmlns:p14="http://schemas.microsoft.com/office/powerpoint/2010/main" val="314088331"/>
+      </p:ext>
+    </p:extLst>
+  </p:cSld>
+  <p:clrMap bg1="lt1" tx1="dk1" bg2="lt2" tx2="dk2" accent1="accent1" accent2="accent2" accent3="accent3" accent4="accent4" accent5="accent5" accent6="accent6" hlink="hlink" folHlink="folHlink"/>
+  <p:notesStyle>
+    <a:lvl1pPr marL="0" algn="l" defTabSz="914400" rtl="0" eaLnBrk="1" latinLnBrk="0" hangingPunct="1">
+      <a:defRPr sz="1200" kern="1200">
+        <a:solidFill>
+          <a:schemeClr val="tx1"/>
+        </a:solidFill>
+        <a:latin typeface="+mn-lt"/>
+        <a:ea typeface="+mn-ea"/>
+        <a:cs typeface="+mn-cs"/>
+      </a:defRPr>
+    </a:lvl1pPr>
+    <a:lvl2pPr marL="457200" algn="l" defTabSz="914400" rtl="0" eaLnBrk="1" latinLnBrk="0" hangingPunct="1">
+      <a:defRPr sz="1200" kern="1200">
+        <a:solidFill>
+          <a:schemeClr val="tx1"/>
+        </a:solidFill>
+        <a:latin typeface="+mn-lt"/>
+        <a:ea typeface="+mn-ea"/>
+        <a:cs typeface="+mn-cs"/>
+      </a:defRPr>
+    </a:lvl2pPr>
+    <a:lvl3pPr marL="914400" algn="l" defTabSz="914400" rtl="0" eaLnBrk="1" latinLnBrk="0" hangingPunct="1">
+      <a:defRPr sz="1200" kern="1200">
+        <a:solidFill>
+          <a:schemeClr val="tx1"/>
+        </a:solidFill>
+        <a:latin typeface="+mn-lt"/>
+        <a:ea typeface="+mn-ea"/>
+        <a:cs typeface="+mn-cs"/>
+      </a:defRPr>
+    </a:lvl3pPr>
+    <a:lvl4pPr marL="1371600" algn="l" defTabSz="914400" rtl="0" eaLnBrk="1" latinLnBrk="0" hangingPunct="1">
+      <a:defRPr sz="1200" kern="1200">
+        <a:solidFill>
+          <a:schemeClr val="tx1"/>
+        </a:solidFill>
+        <a:latin typeface="+mn-lt"/>
+        <a:ea typeface="+mn-ea"/>
+        <a:cs typeface="+mn-cs"/>
+      </a:defRPr>
+    </a:lvl4pPr>
+    <a:lvl5pPr marL="1828800" algn="l" defTabSz="914400" rtl="0" eaLnBrk="1" latinLnBrk="0" hangingPunct="1">
+      <a:defRPr sz="1200" kern="1200">
+        <a:solidFill>
+          <a:schemeClr val="tx1"/>
+        </a:solidFill>
+        <a:latin typeface="+mn-lt"/>
+        <a:ea typeface="+mn-ea"/>
+        <a:cs typeface="+mn-cs"/>
+      </a:defRPr>
+    </a:lvl5pPr>
+    <a:lvl6pPr marL="2286000" algn="l" defTabSz="914400" rtl="0" eaLnBrk="1" latinLnBrk="0" hangingPunct="1">
+      <a:defRPr sz="1200" kern="1200">
+        <a:solidFill>
+          <a:schemeClr val="tx1"/>
+        </a:solidFill>
+        <a:latin typeface="+mn-lt"/>
+        <a:ea typeface="+mn-ea"/>
+        <a:cs typeface="+mn-cs"/>
+      </a:defRPr>
+    </a:lvl6pPr>
+    <a:lvl7pPr marL="2743200" algn="l" defTabSz="914400" rtl="0" eaLnBrk="1" latinLnBrk="0" hangingPunct="1">
+      <a:defRPr sz="1200" kern="1200">
+        <a:solidFill>
+          <a:schemeClr val="tx1"/>
+        </a:solidFill>
+        <a:latin typeface="+mn-lt"/>
+        <a:ea typeface="+mn-ea"/>
+        <a:cs typeface="+mn-cs"/>
+      </a:defRPr>
+    </a:lvl7pPr>
+    <a:lvl8pPr marL="3200400" algn="l" defTabSz="914400" rtl="0" eaLnBrk="1" latinLnBrk="0" hangingPunct="1">
+      <a:defRPr sz="1200" kern="1200">
+        <a:solidFill>
+          <a:schemeClr val="tx1"/>
+        </a:solidFill>
+        <a:latin typeface="+mn-lt"/>
+        <a:ea typeface="+mn-ea"/>
+        <a:cs typeface="+mn-cs"/>
+      </a:defRPr>
+    </a:lvl8pPr>
+    <a:lvl9pPr marL="3657600" algn="l" defTabSz="914400" rtl="0" eaLnBrk="1" latinLnBrk="0" hangingPunct="1">
+      <a:defRPr sz="1200" kern="1200">
+        <a:solidFill>
+          <a:schemeClr val="tx1"/>
+        </a:solidFill>
+        <a:latin typeface="+mn-lt"/>
+        <a:ea typeface="+mn-ea"/>
+        <a:cs typeface="+mn-cs"/>
+      </a:defRPr>
+    </a:lvl9pPr>
+  </p:notesStyle>
+</p:notesMaster>
+</file>
+
+<file path=ppt/notesSlides/notesSlide1.xml><?xml version="1.0" encoding="utf-8"?>
+<p:notes xmlns:a="http://schemas.openxmlformats.org/drawingml/2006/main" xmlns:r="http://schemas.openxmlformats.org/officeDocument/2006/relationships" xmlns:p="http://schemas.openxmlformats.org/presentationml/2006/main">
+  <p:cSld>
+    <p:spTree>
+      <p:nvGrpSpPr>
+        <p:cNvPr id="1" name=""/>
+        <p:cNvGrpSpPr/>
+        <p:nvPr/>
+      </p:nvGrpSpPr>
+      <p:grpSpPr>
+        <a:xfrm>
+          <a:off x="0" y="0"/>
+          <a:ext cx="0" cy="0"/>
+          <a:chOff x="0" y="0"/>
+          <a:chExt cx="0" cy="0"/>
+        </a:xfrm>
+      </p:grpSpPr>
+      <p:sp>
+        <p:nvSpPr>
+          <p:cNvPr id="2" name="Plassholder for lysbilde 1"/>
+          <p:cNvSpPr>
+            <a:spLocks noGrp="1" noRot="1" noChangeAspect="1"/>
+          </p:cNvSpPr>
+          <p:nvPr>
+            <p:ph type="sldImg"/>
+          </p:nvPr>
+        </p:nvSpPr>
+        <p:spPr/>
+      </p:sp>
+      <p:sp>
+        <p:nvSpPr>
+          <p:cNvPr id="3" name="Plassholder for notater 2"/>
+          <p:cNvSpPr>
+            <a:spLocks noGrp="1"/>
+          </p:cNvSpPr>
+          <p:nvPr>
+            <p:ph type="body" idx="1"/>
+          </p:nvPr>
+        </p:nvSpPr>
+        <p:spPr/>
+        <p:txBody>
+          <a:bodyPr/>
+          <a:lstStyle/>
+          <a:p>
+            <a:endParaRPr lang="nb-NO" dirty="0"/>
+          </a:p>
+        </p:txBody>
+      </p:sp>
+      <p:sp>
+        <p:nvSpPr>
+          <p:cNvPr id="4" name="Plassholder for lysbildenummer 3"/>
+          <p:cNvSpPr>
+            <a:spLocks noGrp="1"/>
+          </p:cNvSpPr>
+          <p:nvPr>
+            <p:ph type="sldNum" sz="quarter" idx="5"/>
+          </p:nvPr>
+        </p:nvSpPr>
+        <p:spPr/>
+        <p:txBody>
+          <a:bodyPr/>
+          <a:lstStyle/>
+          <a:p>
+            <a:fld id="{216D7F6F-FEAF-4EC3-9D16-742F1314A19E}" type="slidenum">
+              <a:rPr lang="nb-NO" smtClean="0"/>
+              <a:t>1</a:t>
+            </a:fld>
+            <a:endParaRPr lang="nb-NO"/>
+          </a:p>
+        </p:txBody>
+      </p:sp>
+    </p:spTree>
+    <p:extLst>
+      <p:ext uri="{BB962C8B-B14F-4D97-AF65-F5344CB8AC3E}">
+        <p14:creationId xmlns:p14="http://schemas.microsoft.com/office/powerpoint/2010/main" val="3315378749"/>
+      </p:ext>
+    </p:extLst>
+  </p:cSld>
+  <p:clrMapOvr>
+    <a:masterClrMapping/>
+  </p:clrMapOvr>
+</p:notes>
+</file>
+
+<file path=ppt/notesSlides/notesSlide2.xml><?xml version="1.0" encoding="utf-8"?>
+<p:notes xmlns:a="http://schemas.openxmlformats.org/drawingml/2006/main" xmlns:r="http://schemas.openxmlformats.org/officeDocument/2006/relationships" xmlns:p="http://schemas.openxmlformats.org/presentationml/2006/main">
+  <p:cSld>
+    <p:spTree>
+      <p:nvGrpSpPr>
+        <p:cNvPr id="1" name=""/>
+        <p:cNvGrpSpPr/>
+        <p:nvPr/>
+      </p:nvGrpSpPr>
+      <p:grpSpPr>
+        <a:xfrm>
+          <a:off x="0" y="0"/>
+          <a:ext cx="0" cy="0"/>
+          <a:chOff x="0" y="0"/>
+          <a:chExt cx="0" cy="0"/>
+        </a:xfrm>
+      </p:grpSpPr>
+      <p:sp>
+        <p:nvSpPr>
+          <p:cNvPr id="2" name="Plassholder for lysbilde 1"/>
+          <p:cNvSpPr>
+            <a:spLocks noGrp="1" noRot="1" noChangeAspect="1"/>
+          </p:cNvSpPr>
+          <p:nvPr>
+            <p:ph type="sldImg"/>
+          </p:nvPr>
+        </p:nvSpPr>
+        <p:spPr/>
+      </p:sp>
+      <p:sp>
+        <p:nvSpPr>
+          <p:cNvPr id="3" name="Plassholder for notater 2"/>
+          <p:cNvSpPr>
+            <a:spLocks noGrp="1"/>
+          </p:cNvSpPr>
+          <p:nvPr>
+            <p:ph type="body" idx="1"/>
+          </p:nvPr>
+        </p:nvSpPr>
+        <p:spPr/>
+        <p:txBody>
+          <a:bodyPr/>
+          <a:lstStyle/>
+          <a:p>
+            <a:r>
+              <a:rPr lang="nb-NO" dirty="0" err="1"/>
+              <a:t>We</a:t>
+            </a:r>
+            <a:r>
+              <a:rPr lang="nb-NO" dirty="0"/>
+              <a:t> </a:t>
+            </a:r>
+            <a:r>
+              <a:rPr lang="nb-NO" dirty="0" err="1"/>
+              <a:t>knew</a:t>
+            </a:r>
+            <a:r>
+              <a:rPr lang="nb-NO" dirty="0"/>
+              <a:t> from </a:t>
+            </a:r>
+            <a:r>
+              <a:rPr lang="nb-NO" dirty="0" err="1"/>
+              <a:t>the</a:t>
+            </a:r>
+            <a:r>
+              <a:rPr lang="nb-NO" dirty="0"/>
+              <a:t> start </a:t>
+            </a:r>
+            <a:r>
+              <a:rPr lang="nb-NO" dirty="0" err="1"/>
+              <a:t>that</a:t>
+            </a:r>
+            <a:r>
+              <a:rPr lang="nb-NO" dirty="0"/>
+              <a:t> </a:t>
+            </a:r>
+            <a:r>
+              <a:rPr lang="nb-NO" dirty="0" err="1"/>
+              <a:t>we</a:t>
+            </a:r>
+            <a:r>
+              <a:rPr lang="nb-NO" dirty="0"/>
+              <a:t> </a:t>
+            </a:r>
+            <a:r>
+              <a:rPr lang="nb-NO" dirty="0" err="1"/>
+              <a:t>didn’t</a:t>
+            </a:r>
+            <a:r>
+              <a:rPr lang="nb-NO" dirty="0"/>
+              <a:t> </a:t>
+            </a:r>
+            <a:r>
+              <a:rPr lang="nb-NO" dirty="0" err="1"/>
+              <a:t>want</a:t>
+            </a:r>
+            <a:r>
+              <a:rPr lang="nb-NO" dirty="0"/>
+              <a:t> to </a:t>
+            </a:r>
+            <a:r>
+              <a:rPr lang="nb-NO" dirty="0" err="1"/>
+              <a:t>use</a:t>
+            </a:r>
+            <a:r>
+              <a:rPr lang="nb-NO" dirty="0"/>
+              <a:t> </a:t>
+            </a:r>
+            <a:r>
+              <a:rPr lang="nb-NO" dirty="0" err="1"/>
+              <a:t>too</a:t>
+            </a:r>
+            <a:r>
+              <a:rPr lang="nb-NO" dirty="0"/>
+              <a:t> </a:t>
+            </a:r>
+            <a:r>
+              <a:rPr lang="nb-NO" dirty="0" err="1"/>
+              <a:t>much</a:t>
+            </a:r>
+            <a:r>
+              <a:rPr lang="nb-NO" dirty="0"/>
+              <a:t> time </a:t>
+            </a:r>
+            <a:r>
+              <a:rPr lang="nb-NO" dirty="0" err="1"/>
+              <a:t>on</a:t>
+            </a:r>
+            <a:r>
+              <a:rPr lang="nb-NO" dirty="0"/>
+              <a:t> </a:t>
+            </a:r>
+            <a:r>
+              <a:rPr lang="nb-NO" dirty="0" err="1"/>
+              <a:t>choosing</a:t>
+            </a:r>
+            <a:r>
+              <a:rPr lang="nb-NO" dirty="0"/>
+              <a:t> an </a:t>
+            </a:r>
+            <a:r>
+              <a:rPr lang="nb-NO" dirty="0" err="1"/>
+              <a:t>algorithm</a:t>
+            </a:r>
+            <a:r>
+              <a:rPr lang="nb-NO" dirty="0"/>
+              <a:t>, </a:t>
+            </a:r>
+            <a:r>
+              <a:rPr lang="nb-NO" dirty="0" err="1"/>
+              <a:t>but</a:t>
+            </a:r>
+            <a:r>
+              <a:rPr lang="nb-NO" dirty="0"/>
+              <a:t> </a:t>
+            </a:r>
+            <a:r>
+              <a:rPr lang="nb-NO" dirty="0" err="1"/>
+              <a:t>rather</a:t>
+            </a:r>
+            <a:r>
+              <a:rPr lang="nb-NO" dirty="0"/>
+              <a:t> </a:t>
+            </a:r>
+            <a:r>
+              <a:rPr lang="nb-NO" dirty="0" err="1"/>
+              <a:t>use</a:t>
+            </a:r>
+            <a:r>
+              <a:rPr lang="nb-NO" dirty="0"/>
+              <a:t> more </a:t>
+            </a:r>
+            <a:r>
+              <a:rPr lang="nb-NO" dirty="0" err="1"/>
+              <a:t>of</a:t>
+            </a:r>
+            <a:r>
+              <a:rPr lang="nb-NO" dirty="0"/>
+              <a:t> </a:t>
+            </a:r>
+            <a:r>
+              <a:rPr lang="nb-NO" dirty="0" err="1"/>
+              <a:t>our</a:t>
+            </a:r>
+            <a:r>
+              <a:rPr lang="nb-NO" dirty="0"/>
+              <a:t> time </a:t>
+            </a:r>
+            <a:r>
+              <a:rPr lang="nb-NO" dirty="0" err="1"/>
+              <a:t>on</a:t>
+            </a:r>
+            <a:r>
+              <a:rPr lang="nb-NO" dirty="0"/>
+              <a:t> </a:t>
+            </a:r>
+            <a:r>
+              <a:rPr lang="nb-NO" dirty="0" err="1"/>
+              <a:t>the</a:t>
+            </a:r>
+            <a:r>
+              <a:rPr lang="nb-NO" dirty="0"/>
+              <a:t> </a:t>
+            </a:r>
+            <a:r>
+              <a:rPr lang="nb-NO" dirty="0" err="1"/>
+              <a:t>implementation</a:t>
+            </a:r>
+            <a:r>
+              <a:rPr lang="nb-NO" dirty="0"/>
+              <a:t> </a:t>
+            </a:r>
+            <a:r>
+              <a:rPr lang="nb-NO" dirty="0" err="1"/>
+              <a:t>of</a:t>
+            </a:r>
+            <a:r>
+              <a:rPr lang="nb-NO" dirty="0"/>
+              <a:t> it. </a:t>
+            </a:r>
+          </a:p>
+          <a:p>
+            <a:r>
+              <a:rPr lang="nb-NO" dirty="0" err="1"/>
+              <a:t>When</a:t>
+            </a:r>
+            <a:r>
+              <a:rPr lang="nb-NO" dirty="0"/>
+              <a:t> </a:t>
+            </a:r>
+            <a:r>
+              <a:rPr lang="nb-NO" dirty="0" err="1"/>
+              <a:t>looking</a:t>
+            </a:r>
+            <a:r>
+              <a:rPr lang="nb-NO" dirty="0"/>
+              <a:t> at </a:t>
+            </a:r>
+            <a:r>
+              <a:rPr lang="nb-NO" dirty="0" err="1"/>
+              <a:t>our</a:t>
+            </a:r>
+            <a:r>
+              <a:rPr lang="nb-NO" dirty="0"/>
+              <a:t> </a:t>
+            </a:r>
+            <a:r>
+              <a:rPr lang="nb-NO" dirty="0" err="1"/>
+              <a:t>two</a:t>
+            </a:r>
+            <a:r>
+              <a:rPr lang="nb-NO" dirty="0"/>
+              <a:t> </a:t>
+            </a:r>
+            <a:r>
+              <a:rPr lang="nb-NO" dirty="0" err="1"/>
+              <a:t>options</a:t>
+            </a:r>
+            <a:r>
+              <a:rPr lang="nb-NO" dirty="0"/>
+              <a:t> for </a:t>
+            </a:r>
+            <a:r>
+              <a:rPr lang="nb-NO" dirty="0" err="1"/>
+              <a:t>the</a:t>
+            </a:r>
+            <a:r>
+              <a:rPr lang="nb-NO" dirty="0"/>
+              <a:t> RSA </a:t>
+            </a:r>
+            <a:r>
+              <a:rPr lang="nb-NO" dirty="0" err="1"/>
+              <a:t>algorithm</a:t>
+            </a:r>
+            <a:r>
+              <a:rPr lang="nb-NO" dirty="0"/>
+              <a:t> </a:t>
+            </a:r>
+            <a:r>
+              <a:rPr lang="nb-NO" dirty="0" err="1"/>
+              <a:t>we</a:t>
+            </a:r>
+            <a:r>
+              <a:rPr lang="nb-NO" dirty="0"/>
+              <a:t> </a:t>
+            </a:r>
+            <a:r>
+              <a:rPr lang="nb-NO" dirty="0" err="1"/>
+              <a:t>chose</a:t>
+            </a:r>
+            <a:r>
+              <a:rPr lang="nb-NO" dirty="0"/>
+              <a:t> to </a:t>
+            </a:r>
+            <a:r>
+              <a:rPr lang="nb-NO" dirty="0" err="1"/>
+              <a:t>go</a:t>
+            </a:r>
+            <a:r>
+              <a:rPr lang="nb-NO" dirty="0"/>
+              <a:t> for </a:t>
+            </a:r>
+            <a:r>
+              <a:rPr lang="nb-NO" dirty="0" err="1"/>
+              <a:t>the</a:t>
+            </a:r>
+            <a:r>
+              <a:rPr lang="nb-NO" dirty="0"/>
+              <a:t> </a:t>
+            </a:r>
+            <a:r>
+              <a:rPr lang="nb-NO" dirty="0" err="1"/>
+              <a:t>method</a:t>
+            </a:r>
+            <a:r>
+              <a:rPr lang="nb-NO" dirty="0"/>
+              <a:t> </a:t>
+            </a:r>
+            <a:r>
+              <a:rPr lang="nb-NO" dirty="0" err="1"/>
+              <a:t>that</a:t>
+            </a:r>
+            <a:r>
+              <a:rPr lang="nb-NO" dirty="0"/>
+              <a:t> </a:t>
+            </a:r>
+            <a:r>
+              <a:rPr lang="nb-NO" dirty="0" err="1"/>
+              <a:t>we</a:t>
+            </a:r>
+            <a:r>
+              <a:rPr lang="nb-NO" dirty="0"/>
+              <a:t> </a:t>
+            </a:r>
+            <a:r>
+              <a:rPr lang="nb-NO" dirty="0" err="1"/>
+              <a:t>found</a:t>
+            </a:r>
+            <a:r>
+              <a:rPr lang="nb-NO" dirty="0"/>
+              <a:t> more intuitive. At first </a:t>
+            </a:r>
+            <a:r>
+              <a:rPr lang="nb-NO" dirty="0" err="1"/>
+              <a:t>glance</a:t>
+            </a:r>
+            <a:r>
+              <a:rPr lang="nb-NO" dirty="0"/>
+              <a:t> </a:t>
+            </a:r>
+            <a:r>
+              <a:rPr lang="nb-NO" dirty="0" err="1"/>
+              <a:t>we</a:t>
+            </a:r>
+            <a:r>
+              <a:rPr lang="nb-NO" dirty="0"/>
+              <a:t> </a:t>
+            </a:r>
+            <a:r>
+              <a:rPr lang="nb-NO" dirty="0" err="1"/>
+              <a:t>thought</a:t>
+            </a:r>
+            <a:r>
+              <a:rPr lang="nb-NO" dirty="0"/>
+              <a:t> </a:t>
+            </a:r>
+            <a:r>
+              <a:rPr lang="nb-NO" dirty="0" err="1"/>
+              <a:t>Blaylkley’s</a:t>
+            </a:r>
+            <a:r>
+              <a:rPr lang="nb-NO" dirty="0"/>
+              <a:t> </a:t>
+            </a:r>
+            <a:r>
+              <a:rPr lang="nb-NO" dirty="0" err="1"/>
+              <a:t>method</a:t>
+            </a:r>
+            <a:r>
+              <a:rPr lang="nb-NO" dirty="0"/>
+              <a:t> </a:t>
+            </a:r>
+            <a:r>
+              <a:rPr lang="nb-NO" dirty="0" err="1"/>
+              <a:t>looked</a:t>
+            </a:r>
+            <a:r>
+              <a:rPr lang="nb-NO" dirty="0"/>
+              <a:t> more intuitive and </a:t>
+            </a:r>
+            <a:r>
+              <a:rPr lang="nb-NO" dirty="0" err="1"/>
+              <a:t>that’s</a:t>
+            </a:r>
+            <a:r>
+              <a:rPr lang="nb-NO" dirty="0"/>
+              <a:t> </a:t>
+            </a:r>
+            <a:r>
+              <a:rPr lang="nb-NO" dirty="0" err="1"/>
+              <a:t>why</a:t>
+            </a:r>
+            <a:r>
+              <a:rPr lang="nb-NO" dirty="0"/>
+              <a:t> </a:t>
+            </a:r>
+            <a:r>
+              <a:rPr lang="nb-NO" dirty="0" err="1"/>
+              <a:t>we</a:t>
+            </a:r>
+            <a:r>
+              <a:rPr lang="nb-NO" dirty="0"/>
+              <a:t> </a:t>
+            </a:r>
+            <a:r>
+              <a:rPr lang="nb-NO" dirty="0" err="1"/>
+              <a:t>went</a:t>
+            </a:r>
+            <a:r>
+              <a:rPr lang="nb-NO" dirty="0"/>
+              <a:t> for it. </a:t>
+            </a:r>
+          </a:p>
+        </p:txBody>
+      </p:sp>
+      <p:sp>
+        <p:nvSpPr>
+          <p:cNvPr id="4" name="Plassholder for lysbildenummer 3"/>
+          <p:cNvSpPr>
+            <a:spLocks noGrp="1"/>
+          </p:cNvSpPr>
+          <p:nvPr>
+            <p:ph type="sldNum" sz="quarter" idx="5"/>
+          </p:nvPr>
+        </p:nvSpPr>
+        <p:spPr/>
+        <p:txBody>
+          <a:bodyPr/>
+          <a:lstStyle/>
+          <a:p>
+            <a:fld id="{216D7F6F-FEAF-4EC3-9D16-742F1314A19E}" type="slidenum">
+              <a:rPr lang="nb-NO" smtClean="0"/>
+              <a:t>2</a:t>
+            </a:fld>
+            <a:endParaRPr lang="nb-NO"/>
+          </a:p>
+        </p:txBody>
+      </p:sp>
+    </p:spTree>
+    <p:extLst>
+      <p:ext uri="{BB962C8B-B14F-4D97-AF65-F5344CB8AC3E}">
+        <p14:creationId xmlns:p14="http://schemas.microsoft.com/office/powerpoint/2010/main" val="359513864"/>
+      </p:ext>
+    </p:extLst>
+  </p:cSld>
+  <p:clrMapOvr>
+    <a:masterClrMapping/>
+  </p:clrMapOvr>
+</p:notes>
+</file>
+
+<file path=ppt/notesSlides/notesSlide3.xml><?xml version="1.0" encoding="utf-8"?>
+<p:notes xmlns:a="http://schemas.openxmlformats.org/drawingml/2006/main" xmlns:r="http://schemas.openxmlformats.org/officeDocument/2006/relationships" xmlns:p="http://schemas.openxmlformats.org/presentationml/2006/main">
+  <p:cSld>
+    <p:spTree>
+      <p:nvGrpSpPr>
+        <p:cNvPr id="1" name=""/>
+        <p:cNvGrpSpPr/>
+        <p:nvPr/>
+      </p:nvGrpSpPr>
+      <p:grpSpPr>
+        <a:xfrm>
+          <a:off x="0" y="0"/>
+          <a:ext cx="0" cy="0"/>
+          <a:chOff x="0" y="0"/>
+          <a:chExt cx="0" cy="0"/>
+        </a:xfrm>
+      </p:grpSpPr>
+      <p:sp>
+        <p:nvSpPr>
+          <p:cNvPr id="2" name="Plassholder for lysbilde 1"/>
+          <p:cNvSpPr>
+            <a:spLocks noGrp="1" noRot="1" noChangeAspect="1"/>
+          </p:cNvSpPr>
+          <p:nvPr>
+            <p:ph type="sldImg"/>
+          </p:nvPr>
+        </p:nvSpPr>
+        <p:spPr/>
+      </p:sp>
+      <p:sp>
+        <p:nvSpPr>
+          <p:cNvPr id="3" name="Plassholder for notater 2"/>
+          <p:cNvSpPr>
+            <a:spLocks noGrp="1"/>
+          </p:cNvSpPr>
+          <p:nvPr>
+            <p:ph type="body" idx="1"/>
+          </p:nvPr>
+        </p:nvSpPr>
+        <p:spPr/>
+        <p:txBody>
+          <a:bodyPr/>
+          <a:lstStyle/>
+          <a:p>
+            <a:endParaRPr lang="nb-NO" dirty="0"/>
+          </a:p>
+        </p:txBody>
+      </p:sp>
+      <p:sp>
+        <p:nvSpPr>
+          <p:cNvPr id="4" name="Plassholder for lysbildenummer 3"/>
+          <p:cNvSpPr>
+            <a:spLocks noGrp="1"/>
+          </p:cNvSpPr>
+          <p:nvPr>
+            <p:ph type="sldNum" sz="quarter" idx="5"/>
+          </p:nvPr>
+        </p:nvSpPr>
+        <p:spPr/>
+        <p:txBody>
+          <a:bodyPr/>
+          <a:lstStyle/>
+          <a:p>
+            <a:fld id="{216D7F6F-FEAF-4EC3-9D16-742F1314A19E}" type="slidenum">
+              <a:rPr lang="nb-NO" smtClean="0"/>
+              <a:t>3</a:t>
+            </a:fld>
+            <a:endParaRPr lang="nb-NO"/>
+          </a:p>
+        </p:txBody>
+      </p:sp>
+    </p:spTree>
+    <p:extLst>
+      <p:ext uri="{BB962C8B-B14F-4D97-AF65-F5344CB8AC3E}">
+        <p14:creationId xmlns:p14="http://schemas.microsoft.com/office/powerpoint/2010/main" val="1131720774"/>
+      </p:ext>
+    </p:extLst>
+  </p:cSld>
+  <p:clrMapOvr>
+    <a:masterClrMapping/>
+  </p:clrMapOvr>
+</p:notes>
 </file>
 
 <file path=ppt/slideLayouts/slideLayout1.xml><?xml version="1.0" encoding="utf-8"?>
@@ -3401,6 +4550,35 @@
               <a:t>Group 12</a:t>
             </a:r>
           </a:p>
+          <a:p>
+            <a:r>
+              <a:rPr lang="nb-NO" dirty="0">
+                <a:solidFill>
+                  <a:schemeClr val="bg1">
+                    <a:lumMod val="65000"/>
+                  </a:schemeClr>
+                </a:solidFill>
+              </a:rPr>
+              <a:t> </a:t>
+            </a:r>
+            <a:r>
+              <a:rPr lang="nb-NO" sz="1600" dirty="0">
+                <a:solidFill>
+                  <a:schemeClr val="bg1">
+                    <a:lumMod val="65000"/>
+                  </a:schemeClr>
+                </a:solidFill>
+              </a:rPr>
+              <a:t>Susanne Gripsgård, Ole Jakob Schubert &amp;  Lorang Strand</a:t>
+            </a:r>
+            <a:endParaRPr lang="nb-NO" dirty="0">
+              <a:solidFill>
+                <a:schemeClr val="bg1">
+                  <a:lumMod val="65000"/>
+                </a:schemeClr>
+              </a:solidFill>
+            </a:endParaRPr>
+          </a:p>
         </p:txBody>
       </p:sp>
     </p:spTree>
@@ -3455,8 +4633,12 @@
           <a:lstStyle/>
           <a:p>
             <a:r>
+              <a:rPr lang="nb-NO" dirty="0"/>
+              <a:t>RSA </a:t>
+            </a:r>
+            <a:r>
               <a:rPr lang="nb-NO" dirty="0" err="1"/>
-              <a:t>Algorithm</a:t>
+              <a:t>algorithm</a:t>
             </a:r>
             <a:endParaRPr lang="nb-NO" dirty="0"/>
           </a:p>
@@ -3512,31 +4694,372 @@
           </a:p>
         </p:txBody>
       </p:sp>
-      <p:sp>
-        <p:nvSpPr>
-          <p:cNvPr id="4" name="Plassholder for innhold 3">
-            <a:extLst>
-              <a:ext uri="{FF2B5EF4-FFF2-40B4-BE49-F238E27FC236}">
-                <a16:creationId xmlns:a16="http://schemas.microsoft.com/office/drawing/2014/main" id="{26165546-189D-F8A8-D124-87DCC50CCD4C}"/>
-              </a:ext>
-            </a:extLst>
-          </p:cNvPr>
-          <p:cNvSpPr>
-            <a:spLocks noGrp="1"/>
-          </p:cNvSpPr>
-          <p:nvPr>
-            <p:ph sz="half" idx="2"/>
-          </p:nvPr>
-        </p:nvSpPr>
-        <p:spPr/>
-        <p:txBody>
-          <a:bodyPr/>
-          <a:lstStyle/>
-          <a:p>
-            <a:endParaRPr lang="nb-NO"/>
-          </a:p>
-        </p:txBody>
-      </p:sp>
+      <p:pic>
+        <p:nvPicPr>
+          <p:cNvPr id="6" name="Bilde 5">
+            <a:extLst>
+              <a:ext uri="{FF2B5EF4-FFF2-40B4-BE49-F238E27FC236}">
+                <a16:creationId xmlns:a16="http://schemas.microsoft.com/office/drawing/2014/main" id="{C1293E70-B41A-3755-A887-3348391AB344}"/>
+              </a:ext>
+            </a:extLst>
+          </p:cNvPr>
+          <p:cNvPicPr>
+            <a:picLocks noChangeAspect="1"/>
+          </p:cNvPicPr>
+          <p:nvPr/>
+        </p:nvPicPr>
+        <p:blipFill>
+          <a:blip r:embed="rId3"/>
+          <a:stretch>
+            <a:fillRect/>
+          </a:stretch>
+        </p:blipFill>
+        <p:spPr>
+          <a:xfrm>
+            <a:off x="6955972" y="2002452"/>
+            <a:ext cx="3098022" cy="2119395"/>
+          </a:xfrm>
+          <a:prstGeom prst="rect">
+            <a:avLst/>
+          </a:prstGeom>
+        </p:spPr>
+      </p:pic>
+      <p:pic>
+        <p:nvPicPr>
+          <p:cNvPr id="8" name="Bilde 7">
+            <a:extLst>
+              <a:ext uri="{FF2B5EF4-FFF2-40B4-BE49-F238E27FC236}">
+                <a16:creationId xmlns:a16="http://schemas.microsoft.com/office/drawing/2014/main" id="{6D8FE2F2-3FD3-A3A7-6226-11C0BFFDE89A}"/>
+              </a:ext>
+            </a:extLst>
+          </p:cNvPr>
+          <p:cNvPicPr>
+            <a:picLocks noChangeAspect="1"/>
+          </p:cNvPicPr>
+          <p:nvPr/>
+        </p:nvPicPr>
+        <p:blipFill>
+          <a:blip r:embed="rId4"/>
+          <a:stretch>
+            <a:fillRect/>
+          </a:stretch>
+        </p:blipFill>
+        <p:spPr>
+          <a:xfrm>
+            <a:off x="7081157" y="4557596"/>
+            <a:ext cx="2873830" cy="515075"/>
+          </a:xfrm>
+          <a:prstGeom prst="rect">
+            <a:avLst/>
+          </a:prstGeom>
+        </p:spPr>
+      </p:pic>
+      <mc:AlternateContent xmlns:mc="http://schemas.openxmlformats.org/markup-compatibility/2006">
+        <mc:Choice xmlns:p14="http://schemas.microsoft.com/office/powerpoint/2010/main" Requires="p14">
+          <p:contentPart p14:bwMode="auto" r:id="rId5">
+            <p14:nvContentPartPr>
+              <p14:cNvPr id="10" name="Håndskrift 9">
+                <a:extLst>
+                  <a:ext uri="{FF2B5EF4-FFF2-40B4-BE49-F238E27FC236}">
+                    <a16:creationId xmlns:a16="http://schemas.microsoft.com/office/drawing/2014/main" id="{458C0456-64C9-BBCB-F13F-8C11CDCA2994}"/>
+                  </a:ext>
+                </a:extLst>
+              </p14:cNvPr>
+              <p14:cNvContentPartPr/>
+              <p14:nvPr/>
+            </p14:nvContentPartPr>
+            <p14:xfrm>
+              <a:off x="6547629" y="3706423"/>
+              <a:ext cx="501120" cy="720"/>
+            </p14:xfrm>
+          </p:contentPart>
+        </mc:Choice>
+        <mc:Fallback>
+          <p:pic>
+            <p:nvPicPr>
+              <p:cNvPr id="10" name="Håndskrift 9">
+                <a:extLst>
+                  <a:ext uri="{FF2B5EF4-FFF2-40B4-BE49-F238E27FC236}">
+                    <a16:creationId xmlns:a16="http://schemas.microsoft.com/office/drawing/2014/main" id="{458C0456-64C9-BBCB-F13F-8C11CDCA2994}"/>
+                  </a:ext>
+                </a:extLst>
+              </p:cNvPr>
+              <p:cNvPicPr/>
+              <p:nvPr/>
+            </p:nvPicPr>
+            <p:blipFill>
+              <a:blip r:embed="rId6"/>
+              <a:stretch>
+                <a:fillRect/>
+              </a:stretch>
+            </p:blipFill>
+            <p:spPr>
+              <a:xfrm>
+                <a:off x="6541509" y="3694183"/>
+                <a:ext cx="513360" cy="25200"/>
+              </a:xfrm>
+              <a:prstGeom prst="rect">
+                <a:avLst/>
+              </a:prstGeom>
+            </p:spPr>
+          </p:pic>
+        </mc:Fallback>
+      </mc:AlternateContent>
+      <mc:AlternateContent xmlns:mc="http://schemas.openxmlformats.org/markup-compatibility/2006">
+        <mc:Choice xmlns:p14="http://schemas.microsoft.com/office/powerpoint/2010/main" Requires="p14">
+          <p:contentPart p14:bwMode="auto" r:id="rId7">
+            <p14:nvContentPartPr>
+              <p14:cNvPr id="12" name="Håndskrift 11">
+                <a:extLst>
+                  <a:ext uri="{FF2B5EF4-FFF2-40B4-BE49-F238E27FC236}">
+                    <a16:creationId xmlns:a16="http://schemas.microsoft.com/office/drawing/2014/main" id="{0DF1E228-FE94-486E-96F1-09B1634CFD78}"/>
+                  </a:ext>
+                </a:extLst>
+              </p14:cNvPr>
+              <p14:cNvContentPartPr/>
+              <p14:nvPr/>
+            </p14:nvContentPartPr>
+            <p14:xfrm>
+              <a:off x="6536924" y="3709080"/>
+              <a:ext cx="720" cy="1067760"/>
+            </p14:xfrm>
+          </p:contentPart>
+        </mc:Choice>
+        <mc:Fallback>
+          <p:pic>
+            <p:nvPicPr>
+              <p:cNvPr id="12" name="Håndskrift 11">
+                <a:extLst>
+                  <a:ext uri="{FF2B5EF4-FFF2-40B4-BE49-F238E27FC236}">
+                    <a16:creationId xmlns:a16="http://schemas.microsoft.com/office/drawing/2014/main" id="{0DF1E228-FE94-486E-96F1-09B1634CFD78}"/>
+                  </a:ext>
+                </a:extLst>
+              </p:cNvPr>
+              <p:cNvPicPr/>
+              <p:nvPr/>
+            </p:nvPicPr>
+            <p:blipFill>
+              <a:blip r:embed="rId8"/>
+              <a:stretch>
+                <a:fillRect/>
+              </a:stretch>
+            </p:blipFill>
+            <p:spPr>
+              <a:xfrm>
+                <a:off x="6524684" y="3702960"/>
+                <a:ext cx="25200" cy="1080000"/>
+              </a:xfrm>
+              <a:prstGeom prst="rect">
+                <a:avLst/>
+              </a:prstGeom>
+            </p:spPr>
+          </p:pic>
+        </mc:Fallback>
+      </mc:AlternateContent>
+      <mc:AlternateContent xmlns:mc="http://schemas.openxmlformats.org/markup-compatibility/2006">
+        <mc:Choice xmlns:p14="http://schemas.microsoft.com/office/powerpoint/2010/main" Requires="p14">
+          <p:contentPart p14:bwMode="auto" r:id="rId9">
+            <p14:nvContentPartPr>
+              <p14:cNvPr id="14" name="Håndskrift 13">
+                <a:extLst>
+                  <a:ext uri="{FF2B5EF4-FFF2-40B4-BE49-F238E27FC236}">
+                    <a16:creationId xmlns:a16="http://schemas.microsoft.com/office/drawing/2014/main" id="{E2AD157D-95D5-41AB-7F59-690E7511F27B}"/>
+                  </a:ext>
+                </a:extLst>
+              </p14:cNvPr>
+              <p14:cNvContentPartPr/>
+              <p14:nvPr/>
+            </p14:nvContentPartPr>
+            <p14:xfrm>
+              <a:off x="6536924" y="4789663"/>
+              <a:ext cx="522625" cy="360"/>
+            </p14:xfrm>
+          </p:contentPart>
+        </mc:Choice>
+        <mc:Fallback>
+          <p:pic>
+            <p:nvPicPr>
+              <p:cNvPr id="14" name="Håndskrift 13">
+                <a:extLst>
+                  <a:ext uri="{FF2B5EF4-FFF2-40B4-BE49-F238E27FC236}">
+                    <a16:creationId xmlns:a16="http://schemas.microsoft.com/office/drawing/2014/main" id="{E2AD157D-95D5-41AB-7F59-690E7511F27B}"/>
+                  </a:ext>
+                </a:extLst>
+              </p:cNvPr>
+              <p:cNvPicPr/>
+              <p:nvPr/>
+            </p:nvPicPr>
+            <p:blipFill>
+              <a:blip r:embed="rId10"/>
+              <a:stretch>
+                <a:fillRect/>
+              </a:stretch>
+            </p:blipFill>
+            <p:spPr>
+              <a:xfrm>
+                <a:off x="6530801" y="4783543"/>
+                <a:ext cx="534871" cy="12600"/>
+              </a:xfrm>
+              <a:prstGeom prst="rect">
+                <a:avLst/>
+              </a:prstGeom>
+            </p:spPr>
+          </p:pic>
+        </mc:Fallback>
+      </mc:AlternateContent>
+      <mc:AlternateContent xmlns:mc="http://schemas.openxmlformats.org/markup-compatibility/2006">
+        <mc:Choice xmlns:p14="http://schemas.microsoft.com/office/powerpoint/2010/main" Requires="p14">
+          <p:contentPart p14:bwMode="auto" r:id="rId11">
+            <p14:nvContentPartPr>
+              <p14:cNvPr id="17" name="Håndskrift 16">
+                <a:extLst>
+                  <a:ext uri="{FF2B5EF4-FFF2-40B4-BE49-F238E27FC236}">
+                    <a16:creationId xmlns:a16="http://schemas.microsoft.com/office/drawing/2014/main" id="{F03E2152-CA43-EE02-76F1-A784C92F2F0B}"/>
+                  </a:ext>
+                </a:extLst>
+              </p14:cNvPr>
+              <p14:cNvContentPartPr/>
+              <p14:nvPr/>
+            </p14:nvContentPartPr>
+            <p14:xfrm>
+              <a:off x="7072869" y="4591303"/>
+              <a:ext cx="51840" cy="2520"/>
+            </p14:xfrm>
+          </p:contentPart>
+        </mc:Choice>
+        <mc:Fallback>
+          <p:pic>
+            <p:nvPicPr>
+              <p:cNvPr id="17" name="Håndskrift 16">
+                <a:extLst>
+                  <a:ext uri="{FF2B5EF4-FFF2-40B4-BE49-F238E27FC236}">
+                    <a16:creationId xmlns:a16="http://schemas.microsoft.com/office/drawing/2014/main" id="{F03E2152-CA43-EE02-76F1-A784C92F2F0B}"/>
+                  </a:ext>
+                </a:extLst>
+              </p:cNvPr>
+              <p:cNvPicPr/>
+              <p:nvPr/>
+            </p:nvPicPr>
+            <p:blipFill>
+              <a:blip r:embed="rId12"/>
+              <a:stretch>
+                <a:fillRect/>
+              </a:stretch>
+            </p:blipFill>
+            <p:spPr>
+              <a:xfrm>
+                <a:off x="7066749" y="4585183"/>
+                <a:ext cx="64080" cy="14760"/>
+              </a:xfrm>
+              <a:prstGeom prst="rect">
+                <a:avLst/>
+              </a:prstGeom>
+            </p:spPr>
+          </p:pic>
+        </mc:Fallback>
+      </mc:AlternateContent>
+      <mc:AlternateContent xmlns:mc="http://schemas.openxmlformats.org/markup-compatibility/2006">
+        <mc:Choice xmlns:p14="http://schemas.microsoft.com/office/powerpoint/2010/main" Requires="p14">
+          <p:contentPart p14:bwMode="auto" r:id="rId13">
+            <p14:nvContentPartPr>
+              <p14:cNvPr id="19" name="Håndskrift 18">
+                <a:extLst>
+                  <a:ext uri="{FF2B5EF4-FFF2-40B4-BE49-F238E27FC236}">
+                    <a16:creationId xmlns:a16="http://schemas.microsoft.com/office/drawing/2014/main" id="{BC42F257-2FFA-95EC-3C22-C07561927C6F}"/>
+                  </a:ext>
+                </a:extLst>
+              </p14:cNvPr>
+              <p14:cNvContentPartPr/>
+              <p14:nvPr/>
+            </p14:nvContentPartPr>
+            <p14:xfrm>
+              <a:off x="7064589" y="4598863"/>
+              <a:ext cx="720" cy="419760"/>
+            </p14:xfrm>
+          </p:contentPart>
+        </mc:Choice>
+        <mc:Fallback>
+          <p:pic>
+            <p:nvPicPr>
+              <p:cNvPr id="19" name="Håndskrift 18">
+                <a:extLst>
+                  <a:ext uri="{FF2B5EF4-FFF2-40B4-BE49-F238E27FC236}">
+                    <a16:creationId xmlns:a16="http://schemas.microsoft.com/office/drawing/2014/main" id="{BC42F257-2FFA-95EC-3C22-C07561927C6F}"/>
+                  </a:ext>
+                </a:extLst>
+              </p:cNvPr>
+              <p:cNvPicPr/>
+              <p:nvPr/>
+            </p:nvPicPr>
+            <p:blipFill>
+              <a:blip r:embed="rId14"/>
+              <a:stretch>
+                <a:fillRect/>
+              </a:stretch>
+            </p:blipFill>
+            <p:spPr>
+              <a:xfrm>
+                <a:off x="7052349" y="4592743"/>
+                <a:ext cx="25200" cy="432000"/>
+              </a:xfrm>
+              <a:prstGeom prst="rect">
+                <a:avLst/>
+              </a:prstGeom>
+            </p:spPr>
+          </p:pic>
+        </mc:Fallback>
+      </mc:AlternateContent>
+      <mc:AlternateContent xmlns:mc="http://schemas.openxmlformats.org/markup-compatibility/2006">
+        <mc:Choice xmlns:p14="http://schemas.microsoft.com/office/powerpoint/2010/main" Requires="p14">
+          <p:contentPart p14:bwMode="auto" r:id="rId15">
+            <p14:nvContentPartPr>
+              <p14:cNvPr id="20" name="Håndskrift 19">
+                <a:extLst>
+                  <a:ext uri="{FF2B5EF4-FFF2-40B4-BE49-F238E27FC236}">
+                    <a16:creationId xmlns:a16="http://schemas.microsoft.com/office/drawing/2014/main" id="{1F1CFC87-B052-863D-19CA-ECCF82021AE1}"/>
+                  </a:ext>
+                </a:extLst>
+              </p14:cNvPr>
+              <p14:cNvContentPartPr/>
+              <p14:nvPr/>
+            </p14:nvContentPartPr>
+            <p14:xfrm>
+              <a:off x="7075389" y="5009983"/>
+              <a:ext cx="94320" cy="9000"/>
+            </p14:xfrm>
+          </p:contentPart>
+        </mc:Choice>
+        <mc:Fallback>
+          <p:pic>
+            <p:nvPicPr>
+              <p:cNvPr id="20" name="Håndskrift 19">
+                <a:extLst>
+                  <a:ext uri="{FF2B5EF4-FFF2-40B4-BE49-F238E27FC236}">
+                    <a16:creationId xmlns:a16="http://schemas.microsoft.com/office/drawing/2014/main" id="{1F1CFC87-B052-863D-19CA-ECCF82021AE1}"/>
+                  </a:ext>
+                </a:extLst>
+              </p:cNvPr>
+              <p:cNvPicPr/>
+              <p:nvPr/>
+            </p:nvPicPr>
+            <p:blipFill>
+              <a:blip r:embed="rId16"/>
+              <a:stretch>
+                <a:fillRect/>
+              </a:stretch>
+            </p:blipFill>
+            <p:spPr>
+              <a:xfrm>
+                <a:off x="7069269" y="5003863"/>
+                <a:ext cx="106560" cy="21240"/>
+              </a:xfrm>
+              <a:prstGeom prst="rect">
+                <a:avLst/>
+              </a:prstGeom>
+            </p:spPr>
+          </p:pic>
+        </mc:Fallback>
+      </mc:AlternateContent>
     </p:spTree>
     <p:extLst>
       <p:ext uri="{BB962C8B-B14F-4D97-AF65-F5344CB8AC3E}">
@@ -3628,32 +5151,17 @@
           <a:bodyPr/>
           <a:lstStyle/>
           <a:p>
-            <a:endParaRPr lang="nb-NO"/>
-          </a:p>
-        </p:txBody>
-      </p:sp>
-      <p:sp>
-        <p:nvSpPr>
-          <p:cNvPr id="4" name="Plassholder for innhold 3">
-            <a:extLst>
-              <a:ext uri="{FF2B5EF4-FFF2-40B4-BE49-F238E27FC236}">
-                <a16:creationId xmlns:a16="http://schemas.microsoft.com/office/drawing/2014/main" id="{E55446D2-D028-BB1A-8870-1C7A55AA82BA}"/>
-              </a:ext>
-            </a:extLst>
-          </p:cNvPr>
-          <p:cNvSpPr>
-            <a:spLocks noGrp="1"/>
-          </p:cNvSpPr>
-          <p:nvPr>
-            <p:ph sz="half" idx="2"/>
-          </p:nvPr>
-        </p:nvSpPr>
-        <p:spPr/>
-        <p:txBody>
-          <a:bodyPr/>
-          <a:lstStyle/>
-          <a:p>
-            <a:endParaRPr lang="nb-NO"/>
+            <a:pPr marL="0" indent="0">
+              <a:buNone/>
+            </a:pPr>
+            <a:r>
+              <a:rPr lang="nb-NO" dirty="0">
+                <a:solidFill>
+                  <a:srgbClr val="FF0000"/>
+                </a:solidFill>
+              </a:rPr>
+              <a:t>Legg inn bilde av topp-nivået her</a:t>
+            </a:r>
           </a:p>
         </p:txBody>
       </p:sp>
@@ -3748,32 +5256,20 @@
           <a:bodyPr/>
           <a:lstStyle/>
           <a:p>
-            <a:endParaRPr lang="nb-NO"/>
-          </a:p>
-        </p:txBody>
-      </p:sp>
-      <p:sp>
-        <p:nvSpPr>
-          <p:cNvPr id="4" name="Plassholder for innhold 3">
-            <a:extLst>
-              <a:ext uri="{FF2B5EF4-FFF2-40B4-BE49-F238E27FC236}">
-                <a16:creationId xmlns:a16="http://schemas.microsoft.com/office/drawing/2014/main" id="{7D796113-391F-E02B-072A-60E13B3E7D2F}"/>
-              </a:ext>
-            </a:extLst>
-          </p:cNvPr>
-          <p:cNvSpPr>
-            <a:spLocks noGrp="1"/>
-          </p:cNvSpPr>
-          <p:nvPr>
-            <p:ph sz="half" idx="2"/>
-          </p:nvPr>
-        </p:nvSpPr>
-        <p:spPr/>
-        <p:txBody>
-          <a:bodyPr/>
-          <a:lstStyle/>
-          <a:p>
-            <a:endParaRPr lang="nb-NO"/>
+            <a:endParaRPr lang="nb-NO" dirty="0"/>
+          </a:p>
+          <a:p>
+            <a:pPr marL="0" indent="0">
+              <a:buNone/>
+            </a:pPr>
+            <a:r>
+              <a:rPr lang="nb-NO" dirty="0">
+                <a:solidFill>
+                  <a:srgbClr val="FF0000"/>
+                </a:solidFill>
+              </a:rPr>
+              <a:t>Legg inn bilde av de lavere nivåene her</a:t>
+            </a:r>
           </a:p>
         </p:txBody>
       </p:sp>
@@ -3857,7 +5353,23 @@
           <a:bodyPr/>
           <a:lstStyle/>
           <a:p>
+            <a:pPr marL="0" indent="0">
+              <a:buNone/>
+            </a:pPr>
             <a:endParaRPr lang="nb-NO" dirty="0"/>
+          </a:p>
+          <a:p>
+            <a:pPr marL="0" indent="0">
+              <a:buNone/>
+            </a:pPr>
+            <a:r>
+              <a:rPr lang="nb-NO" dirty="0">
+                <a:solidFill>
+                  <a:srgbClr val="FF0000"/>
+                </a:solidFill>
+              </a:rPr>
+              <a:t>Gjør estimat når mikroarkitekturen er ferdig</a:t>
+            </a:r>
           </a:p>
         </p:txBody>
       </p:sp>
@@ -4212,4 +5724,319 @@
     </a:ext>
   </a:extLst>
 </a:theme>
+</file>
+
+<file path=ppt/theme/theme2.xml><?xml version="1.0" encoding="utf-8"?>
+<a:theme xmlns:a="http://schemas.openxmlformats.org/drawingml/2006/main" name="Office-tema">
+  <a:themeElements>
+    <a:clrScheme name="Office">
+      <a:dk1>
+        <a:sysClr val="windowText" lastClr="000000"/>
+      </a:dk1>
+      <a:lt1>
+        <a:sysClr val="window" lastClr="FFFFFF"/>
+      </a:lt1>
+      <a:dk2>
+        <a:srgbClr val="0E2841"/>
+      </a:dk2>
+      <a:lt2>
+        <a:srgbClr val="E8E8E8"/>
+      </a:lt2>
+      <a:accent1>
+        <a:srgbClr val="156082"/>
+      </a:accent1>
+      <a:accent2>
+        <a:srgbClr val="E97132"/>
+      </a:accent2>
+      <a:accent3>
+        <a:srgbClr val="196B24"/>
+      </a:accent3>
+      <a:accent4>
+        <a:srgbClr val="0F9ED5"/>
+      </a:accent4>
+      <a:accent5>
+        <a:srgbClr val="A02B93"/>
+      </a:accent5>
+      <a:accent6>
+        <a:srgbClr val="4EA72E"/>
+      </a:accent6>
+      <a:hlink>
+        <a:srgbClr val="467886"/>
+      </a:hlink>
+      <a:folHlink>
+        <a:srgbClr val="96607D"/>
+      </a:folHlink>
+    </a:clrScheme>
+    <a:fontScheme name="Office">
+      <a:majorFont>
+        <a:latin typeface="Aptos Display" panose="02110004020202020204"/>
+        <a:ea typeface=""/>
+        <a:cs typeface=""/>
+        <a:font script="Jpan" typeface="游ゴシック Light"/>
+        <a:font script="Hang" typeface="맑은 고딕"/>
+        <a:font script="Hans" typeface="等线 Light"/>
+        <a:font script="Hant" typeface="新細明體"/>
+        <a:font script="Arab" typeface="Times New Roman"/>
+        <a:font script="Hebr" typeface="Times New Roman"/>
+        <a:font script="Thai" typeface="Angsana New"/>
+        <a:font script="Ethi" typeface="Nyala"/>
+        <a:font script="Beng" typeface="Vrinda"/>
+        <a:font script="Gujr" typeface="Shruti"/>
+        <a:font script="Khmr" typeface="MoolBoran"/>
+        <a:font script="Knda" typeface="Tunga"/>
+        <a:font script="Guru" typeface="Raavi"/>
+        <a:font script="Cans" typeface="Euphemia"/>
+        <a:font script="Cher" typeface="Plantagenet Cherokee"/>
+        <a:font script="Yiii" typeface="Microsoft Yi Baiti"/>
+        <a:font script="Tibt" typeface="Microsoft Himalaya"/>
+        <a:font script="Thaa" typeface="MV Boli"/>
+        <a:font script="Deva" typeface="Mangal"/>
+        <a:font script="Telu" typeface="Gautami"/>
+        <a:font script="Taml" typeface="Latha"/>
+        <a:font script="Syrc" typeface="Estrangelo Edessa"/>
+        <a:font script="Orya" typeface="Kalinga"/>
+        <a:font script="Mlym" typeface="Kartika"/>
+        <a:font script="Laoo" typeface="DokChampa"/>
+        <a:font script="Sinh" typeface="Iskoola Pota"/>
+        <a:font script="Mong" typeface="Mongolian Baiti"/>
+        <a:font script="Viet" typeface="Times New Roman"/>
+        <a:font script="Uigh" typeface="Microsoft Uighur"/>
+        <a:font script="Geor" typeface="Sylfaen"/>
+        <a:font script="Armn" typeface="Arial"/>
+        <a:font script="Bugi" typeface="Leelawadee UI"/>
+        <a:font script="Bopo" typeface="Microsoft JhengHei"/>
+        <a:font script="Java" typeface="Javanese Text"/>
+        <a:font script="Lisu" typeface="Segoe UI"/>
+        <a:font script="Mymr" typeface="Myanmar Text"/>
+        <a:font script="Nkoo" typeface="Ebrima"/>
+        <a:font script="Olck" typeface="Nirmala UI"/>
+        <a:font script="Osma" typeface="Ebrima"/>
+        <a:font script="Phag" typeface="Phagspa"/>
+        <a:font script="Syrn" typeface="Estrangelo Edessa"/>
+        <a:font script="Syrj" typeface="Estrangelo Edessa"/>
+        <a:font script="Syre" typeface="Estrangelo Edessa"/>
+        <a:font script="Sora" typeface="Nirmala UI"/>
+        <a:font script="Tale" typeface="Microsoft Tai Le"/>
+        <a:font script="Talu" typeface="Microsoft New Tai Lue"/>
+        <a:font script="Tfng" typeface="Ebrima"/>
+      </a:majorFont>
+      <a:minorFont>
+        <a:latin typeface="Aptos" panose="02110004020202020204"/>
+        <a:ea typeface=""/>
+        <a:cs typeface=""/>
+        <a:font script="Jpan" typeface="游ゴシック"/>
+        <a:font script="Hang" typeface="맑은 고딕"/>
+        <a:font script="Hans" typeface="等线"/>
+        <a:font script="Hant" typeface="新細明體"/>
+        <a:font script="Arab" typeface="Arial"/>
+        <a:font script="Hebr" typeface="Arial"/>
+        <a:font script="Thai" typeface="Cordia New"/>
+        <a:font script="Ethi" typeface="Nyala"/>
+        <a:font script="Beng" typeface="Vrinda"/>
+        <a:font script="Gujr" typeface="Shruti"/>
+        <a:font script="Khmr" typeface="DaunPenh"/>
+        <a:font script="Knda" typeface="Tunga"/>
+        <a:font script="Guru" typeface="Raavi"/>
+        <a:font script="Cans" typeface="Euphemia"/>
+        <a:font script="Cher" typeface="Plantagenet Cherokee"/>
+        <a:font script="Yiii" typeface="Microsoft Yi Baiti"/>
+        <a:font script="Tibt" typeface="Microsoft Himalaya"/>
+        <a:font script="Thaa" typeface="MV Boli"/>
+        <a:font script="Deva" typeface="Mangal"/>
+        <a:font script="Telu" typeface="Gautami"/>
+        <a:font script="Taml" typeface="Latha"/>
+        <a:font script="Syrc" typeface="Estrangelo Edessa"/>
+        <a:font script="Orya" typeface="Kalinga"/>
+        <a:font script="Mlym" typeface="Kartika"/>
+        <a:font script="Laoo" typeface="DokChampa"/>
+        <a:font script="Sinh" typeface="Iskoola Pota"/>
+        <a:font script="Mong" typeface="Mongolian Baiti"/>
+        <a:font script="Viet" typeface="Arial"/>
+        <a:font script="Uigh" typeface="Microsoft Uighur"/>
+        <a:font script="Geor" typeface="Sylfaen"/>
+        <a:font script="Armn" typeface="Arial"/>
+        <a:font script="Bugi" typeface="Leelawadee UI"/>
+        <a:font script="Bopo" typeface="Microsoft JhengHei"/>
+        <a:font script="Java" typeface="Javanese Text"/>
+        <a:font script="Lisu" typeface="Segoe UI"/>
+        <a:font script="Mymr" typeface="Myanmar Text"/>
+        <a:font script="Nkoo" typeface="Ebrima"/>
+        <a:font script="Olck" typeface="Nirmala UI"/>
+        <a:font script="Osma" typeface="Ebrima"/>
+        <a:font script="Phag" typeface="Phagspa"/>
+        <a:font script="Syrn" typeface="Estrangelo Edessa"/>
+        <a:font script="Syrj" typeface="Estrangelo Edessa"/>
+        <a:font script="Syre" typeface="Estrangelo Edessa"/>
+        <a:font script="Sora" typeface="Nirmala UI"/>
+        <a:font script="Tale" typeface="Microsoft Tai Le"/>
+        <a:font script="Talu" typeface="Microsoft New Tai Lue"/>
+        <a:font script="Tfng" typeface="Ebrima"/>
+      </a:minorFont>
+    </a:fontScheme>
+    <a:fmtScheme name="Office">
+      <a:fillStyleLst>
+        <a:solidFill>
+          <a:schemeClr val="phClr"/>
+        </a:solidFill>
+        <a:gradFill rotWithShape="1">
+          <a:gsLst>
+            <a:gs pos="0">
+              <a:schemeClr val="phClr">
+                <a:lumMod val="110000"/>
+                <a:satMod val="105000"/>
+                <a:tint val="67000"/>
+              </a:schemeClr>
+            </a:gs>
+            <a:gs pos="50000">
+              <a:schemeClr val="phClr">
+                <a:lumMod val="105000"/>
+                <a:satMod val="103000"/>
+                <a:tint val="73000"/>
+              </a:schemeClr>
+            </a:gs>
+            <a:gs pos="100000">
+              <a:schemeClr val="phClr">
+                <a:lumMod val="105000"/>
+                <a:satMod val="109000"/>
+                <a:tint val="81000"/>
+              </a:schemeClr>
+            </a:gs>
+          </a:gsLst>
+          <a:lin ang="5400000" scaled="0"/>
+        </a:gradFill>
+        <a:gradFill rotWithShape="1">
+          <a:gsLst>
+            <a:gs pos="0">
+              <a:schemeClr val="phClr">
+                <a:satMod val="103000"/>
+                <a:lumMod val="102000"/>
+                <a:tint val="94000"/>
+              </a:schemeClr>
+            </a:gs>
+            <a:gs pos="50000">
+              <a:schemeClr val="phClr">
+                <a:satMod val="110000"/>
+                <a:lumMod val="100000"/>
+                <a:shade val="100000"/>
+              </a:schemeClr>
+            </a:gs>
+            <a:gs pos="100000">
+              <a:schemeClr val="phClr">
+                <a:lumMod val="99000"/>
+                <a:satMod val="120000"/>
+                <a:shade val="78000"/>
+              </a:schemeClr>
+            </a:gs>
+          </a:gsLst>
+          <a:lin ang="5400000" scaled="0"/>
+        </a:gradFill>
+      </a:fillStyleLst>
+      <a:lnStyleLst>
+        <a:ln w="12700" cap="flat" cmpd="sng" algn="ctr">
+          <a:solidFill>
+            <a:schemeClr val="phClr"/>
+          </a:solidFill>
+          <a:prstDash val="solid"/>
+          <a:miter lim="800000"/>
+        </a:ln>
+        <a:ln w="19050" cap="flat" cmpd="sng" algn="ctr">
+          <a:solidFill>
+            <a:schemeClr val="phClr"/>
+          </a:solidFill>
+          <a:prstDash val="solid"/>
+          <a:miter lim="800000"/>
+        </a:ln>
+        <a:ln w="25400" cap="flat" cmpd="sng" algn="ctr">
+          <a:solidFill>
+            <a:schemeClr val="phClr"/>
+          </a:solidFill>
+          <a:prstDash val="solid"/>
+          <a:miter lim="800000"/>
+        </a:ln>
+      </a:lnStyleLst>
+      <a:effectStyleLst>
+        <a:effectStyle>
+          <a:effectLst/>
+        </a:effectStyle>
+        <a:effectStyle>
+          <a:effectLst/>
+        </a:effectStyle>
+        <a:effectStyle>
+          <a:effectLst>
+            <a:outerShdw blurRad="57150" dist="19050" dir="5400000" algn="ctr" rotWithShape="0">
+              <a:srgbClr val="000000">
+                <a:alpha val="63000"/>
+              </a:srgbClr>
+            </a:outerShdw>
+          </a:effectLst>
+        </a:effectStyle>
+      </a:effectStyleLst>
+      <a:bgFillStyleLst>
+        <a:solidFill>
+          <a:schemeClr val="phClr"/>
+        </a:solidFill>
+        <a:solidFill>
+          <a:schemeClr val="phClr">
+            <a:tint val="95000"/>
+            <a:satMod val="170000"/>
+          </a:schemeClr>
+        </a:solidFill>
+        <a:gradFill rotWithShape="1">
+          <a:gsLst>
+            <a:gs pos="0">
+              <a:schemeClr val="phClr">
+                <a:tint val="93000"/>
+                <a:satMod val="150000"/>
+                <a:shade val="98000"/>
+                <a:lumMod val="102000"/>
+              </a:schemeClr>
+            </a:gs>
+            <a:gs pos="50000">
+              <a:schemeClr val="phClr">
+                <a:tint val="98000"/>
+                <a:satMod val="130000"/>
+                <a:shade val="90000"/>
+                <a:lumMod val="103000"/>
+              </a:schemeClr>
+            </a:gs>
+            <a:gs pos="100000">
+              <a:schemeClr val="phClr">
+                <a:shade val="63000"/>
+                <a:satMod val="120000"/>
+              </a:schemeClr>
+            </a:gs>
+          </a:gsLst>
+          <a:lin ang="5400000" scaled="0"/>
+        </a:gradFill>
+      </a:bgFillStyleLst>
+    </a:fmtScheme>
+  </a:themeElements>
+  <a:objectDefaults>
+    <a:lnDef>
+      <a:spPr/>
+      <a:bodyPr/>
+      <a:lstStyle/>
+      <a:style>
+        <a:lnRef idx="2">
+          <a:schemeClr val="accent1"/>
+        </a:lnRef>
+        <a:fillRef idx="0">
+          <a:schemeClr val="accent1"/>
+        </a:fillRef>
+        <a:effectRef idx="1">
+          <a:schemeClr val="accent1"/>
+        </a:effectRef>
+        <a:fontRef idx="minor">
+          <a:schemeClr val="tx1"/>
+        </a:fontRef>
+      </a:style>
+    </a:lnDef>
+  </a:objectDefaults>
+  <a:extraClrSchemeLst/>
+  <a:extLst>
+    <a:ext uri="{05A4C25C-085E-4340-85A3-A5531E510DB2}">
+      <thm15:themeFamily xmlns:thm15="http://schemas.microsoft.com/office/thememl/2012/main" name="Office Theme" id="{2E142A2C-CD16-42D6-873A-C26D2A0506FA}" vid="{1BDDFF52-6CD6-40A5-AB3C-68EB2F1E4D0A}"/>
+    </a:ext>
+  </a:extLst>
+</a:theme>
 </file>
</xml_diff>

<commit_message>
made png figures and added in ppt
</commit_message>
<xml_diff>
--- a/TermProject/Microarchitecture_presentation.pptx
+++ b/TermProject/Microarchitecture_presentation.pptx
@@ -111,6 +111,11 @@
       </a:defRPr>
     </a:lvl9pPr>
   </p:defaultTextStyle>
+  <p:extLst>
+    <p:ext uri="{EFAFB233-063F-42B5-8137-9DF3F51BA10A}">
+      <p15:sldGuideLst xmlns:p15="http://schemas.microsoft.com/office/powerpoint/2012/main"/>
+    </p:ext>
+  </p:extLst>
 </p:presentation>
 </file>
 
@@ -364,7 +369,7 @@
           <a:p>
             <a:fld id="{F4BB8A02-1B8F-4CA0-82C6-CD71F4E181AC}" type="datetimeFigureOut">
               <a:rPr lang="nb-NO" smtClean="0"/>
-              <a:t>26.09.2025</a:t>
+              <a:t>29.09.2025</a:t>
             </a:fld>
             <a:endParaRPr lang="nb-NO"/>
           </a:p>
@@ -1407,7 +1412,7 @@
           <a:p>
             <a:fld id="{AB450C0E-87F3-42F7-9C88-607322746BDD}" type="datetimeFigureOut">
               <a:rPr lang="nb-NO" smtClean="0"/>
-              <a:t>26.09.2025</a:t>
+              <a:t>29.09.2025</a:t>
             </a:fld>
             <a:endParaRPr lang="nb-NO"/>
           </a:p>
@@ -1605,7 +1610,7 @@
           <a:p>
             <a:fld id="{AB450C0E-87F3-42F7-9C88-607322746BDD}" type="datetimeFigureOut">
               <a:rPr lang="nb-NO" smtClean="0"/>
-              <a:t>26.09.2025</a:t>
+              <a:t>29.09.2025</a:t>
             </a:fld>
             <a:endParaRPr lang="nb-NO"/>
           </a:p>
@@ -1813,7 +1818,7 @@
           <a:p>
             <a:fld id="{AB450C0E-87F3-42F7-9C88-607322746BDD}" type="datetimeFigureOut">
               <a:rPr lang="nb-NO" smtClean="0"/>
-              <a:t>26.09.2025</a:t>
+              <a:t>29.09.2025</a:t>
             </a:fld>
             <a:endParaRPr lang="nb-NO"/>
           </a:p>
@@ -2011,7 +2016,7 @@
           <a:p>
             <a:fld id="{AB450C0E-87F3-42F7-9C88-607322746BDD}" type="datetimeFigureOut">
               <a:rPr lang="nb-NO" smtClean="0"/>
-              <a:t>26.09.2025</a:t>
+              <a:t>29.09.2025</a:t>
             </a:fld>
             <a:endParaRPr lang="nb-NO"/>
           </a:p>
@@ -2286,7 +2291,7 @@
           <a:p>
             <a:fld id="{AB450C0E-87F3-42F7-9C88-607322746BDD}" type="datetimeFigureOut">
               <a:rPr lang="nb-NO" smtClean="0"/>
-              <a:t>26.09.2025</a:t>
+              <a:t>29.09.2025</a:t>
             </a:fld>
             <a:endParaRPr lang="nb-NO"/>
           </a:p>
@@ -2551,7 +2556,7 @@
           <a:p>
             <a:fld id="{AB450C0E-87F3-42F7-9C88-607322746BDD}" type="datetimeFigureOut">
               <a:rPr lang="nb-NO" smtClean="0"/>
-              <a:t>26.09.2025</a:t>
+              <a:t>29.09.2025</a:t>
             </a:fld>
             <a:endParaRPr lang="nb-NO"/>
           </a:p>
@@ -2963,7 +2968,7 @@
           <a:p>
             <a:fld id="{AB450C0E-87F3-42F7-9C88-607322746BDD}" type="datetimeFigureOut">
               <a:rPr lang="nb-NO" smtClean="0"/>
-              <a:t>26.09.2025</a:t>
+              <a:t>29.09.2025</a:t>
             </a:fld>
             <a:endParaRPr lang="nb-NO"/>
           </a:p>
@@ -3104,7 +3109,7 @@
           <a:p>
             <a:fld id="{AB450C0E-87F3-42F7-9C88-607322746BDD}" type="datetimeFigureOut">
               <a:rPr lang="nb-NO" smtClean="0"/>
-              <a:t>26.09.2025</a:t>
+              <a:t>29.09.2025</a:t>
             </a:fld>
             <a:endParaRPr lang="nb-NO"/>
           </a:p>
@@ -3217,7 +3222,7 @@
           <a:p>
             <a:fld id="{AB450C0E-87F3-42F7-9C88-607322746BDD}" type="datetimeFigureOut">
               <a:rPr lang="nb-NO" smtClean="0"/>
-              <a:t>26.09.2025</a:t>
+              <a:t>29.09.2025</a:t>
             </a:fld>
             <a:endParaRPr lang="nb-NO"/>
           </a:p>
@@ -3528,7 +3533,7 @@
           <a:p>
             <a:fld id="{AB450C0E-87F3-42F7-9C88-607322746BDD}" type="datetimeFigureOut">
               <a:rPr lang="nb-NO" smtClean="0"/>
-              <a:t>26.09.2025</a:t>
+              <a:t>29.09.2025</a:t>
             </a:fld>
             <a:endParaRPr lang="nb-NO"/>
           </a:p>
@@ -3816,7 +3821,7 @@
           <a:p>
             <a:fld id="{AB450C0E-87F3-42F7-9C88-607322746BDD}" type="datetimeFigureOut">
               <a:rPr lang="nb-NO" smtClean="0"/>
-              <a:t>26.09.2025</a:t>
+              <a:t>29.09.2025</a:t>
             </a:fld>
             <a:endParaRPr lang="nb-NO"/>
           </a:p>
@@ -4057,7 +4062,7 @@
           <a:p>
             <a:fld id="{AB450C0E-87F3-42F7-9C88-607322746BDD}" type="datetimeFigureOut">
               <a:rPr lang="nb-NO" smtClean="0"/>
-              <a:t>26.09.2025</a:t>
+              <a:t>29.09.2025</a:t>
             </a:fld>
             <a:endParaRPr lang="nb-NO"/>
           </a:p>
@@ -4754,8 +4759,8 @@
           </a:prstGeom>
         </p:spPr>
       </p:pic>
-      <mc:AlternateContent xmlns:mc="http://schemas.openxmlformats.org/markup-compatibility/2006">
-        <mc:Choice xmlns:p14="http://schemas.microsoft.com/office/powerpoint/2010/main" Requires="p14">
+      <mc:AlternateContent xmlns:mc="http://schemas.openxmlformats.org/markup-compatibility/2006" xmlns:p14="http://schemas.microsoft.com/office/powerpoint/2010/main">
+        <mc:Choice Requires="p14">
           <p:contentPart p14:bwMode="auto" r:id="rId5">
             <p14:nvContentPartPr>
               <p14:cNvPr id="10" name="Håndskrift 9">
@@ -4774,7 +4779,7 @@
             </p14:xfrm>
           </p:contentPart>
         </mc:Choice>
-        <mc:Fallback>
+        <mc:Fallback xmlns="">
           <p:pic>
             <p:nvPicPr>
               <p:cNvPr id="10" name="Håndskrift 9">
@@ -4805,8 +4810,8 @@
           </p:pic>
         </mc:Fallback>
       </mc:AlternateContent>
-      <mc:AlternateContent xmlns:mc="http://schemas.openxmlformats.org/markup-compatibility/2006">
-        <mc:Choice xmlns:p14="http://schemas.microsoft.com/office/powerpoint/2010/main" Requires="p14">
+      <mc:AlternateContent xmlns:mc="http://schemas.openxmlformats.org/markup-compatibility/2006" xmlns:p14="http://schemas.microsoft.com/office/powerpoint/2010/main">
+        <mc:Choice Requires="p14">
           <p:contentPart p14:bwMode="auto" r:id="rId7">
             <p14:nvContentPartPr>
               <p14:cNvPr id="12" name="Håndskrift 11">
@@ -4825,7 +4830,7 @@
             </p14:xfrm>
           </p:contentPart>
         </mc:Choice>
-        <mc:Fallback>
+        <mc:Fallback xmlns="">
           <p:pic>
             <p:nvPicPr>
               <p:cNvPr id="12" name="Håndskrift 11">
@@ -4856,8 +4861,8 @@
           </p:pic>
         </mc:Fallback>
       </mc:AlternateContent>
-      <mc:AlternateContent xmlns:mc="http://schemas.openxmlformats.org/markup-compatibility/2006">
-        <mc:Choice xmlns:p14="http://schemas.microsoft.com/office/powerpoint/2010/main" Requires="p14">
+      <mc:AlternateContent xmlns:mc="http://schemas.openxmlformats.org/markup-compatibility/2006" xmlns:p14="http://schemas.microsoft.com/office/powerpoint/2010/main">
+        <mc:Choice Requires="p14">
           <p:contentPart p14:bwMode="auto" r:id="rId9">
             <p14:nvContentPartPr>
               <p14:cNvPr id="14" name="Håndskrift 13">
@@ -4876,7 +4881,7 @@
             </p14:xfrm>
           </p:contentPart>
         </mc:Choice>
-        <mc:Fallback>
+        <mc:Fallback xmlns="">
           <p:pic>
             <p:nvPicPr>
               <p:cNvPr id="14" name="Håndskrift 13">
@@ -4907,8 +4912,8 @@
           </p:pic>
         </mc:Fallback>
       </mc:AlternateContent>
-      <mc:AlternateContent xmlns:mc="http://schemas.openxmlformats.org/markup-compatibility/2006">
-        <mc:Choice xmlns:p14="http://schemas.microsoft.com/office/powerpoint/2010/main" Requires="p14">
+      <mc:AlternateContent xmlns:mc="http://schemas.openxmlformats.org/markup-compatibility/2006" xmlns:p14="http://schemas.microsoft.com/office/powerpoint/2010/main">
+        <mc:Choice Requires="p14">
           <p:contentPart p14:bwMode="auto" r:id="rId11">
             <p14:nvContentPartPr>
               <p14:cNvPr id="17" name="Håndskrift 16">
@@ -4927,7 +4932,7 @@
             </p14:xfrm>
           </p:contentPart>
         </mc:Choice>
-        <mc:Fallback>
+        <mc:Fallback xmlns="">
           <p:pic>
             <p:nvPicPr>
               <p:cNvPr id="17" name="Håndskrift 16">
@@ -4958,8 +4963,8 @@
           </p:pic>
         </mc:Fallback>
       </mc:AlternateContent>
-      <mc:AlternateContent xmlns:mc="http://schemas.openxmlformats.org/markup-compatibility/2006">
-        <mc:Choice xmlns:p14="http://schemas.microsoft.com/office/powerpoint/2010/main" Requires="p14">
+      <mc:AlternateContent xmlns:mc="http://schemas.openxmlformats.org/markup-compatibility/2006" xmlns:p14="http://schemas.microsoft.com/office/powerpoint/2010/main">
+        <mc:Choice Requires="p14">
           <p:contentPart p14:bwMode="auto" r:id="rId13">
             <p14:nvContentPartPr>
               <p14:cNvPr id="19" name="Håndskrift 18">
@@ -4978,7 +4983,7 @@
             </p14:xfrm>
           </p:contentPart>
         </mc:Choice>
-        <mc:Fallback>
+        <mc:Fallback xmlns="">
           <p:pic>
             <p:nvPicPr>
               <p:cNvPr id="19" name="Håndskrift 18">
@@ -5009,8 +5014,8 @@
           </p:pic>
         </mc:Fallback>
       </mc:AlternateContent>
-      <mc:AlternateContent xmlns:mc="http://schemas.openxmlformats.org/markup-compatibility/2006">
-        <mc:Choice xmlns:p14="http://schemas.microsoft.com/office/powerpoint/2010/main" Requires="p14">
+      <mc:AlternateContent xmlns:mc="http://schemas.openxmlformats.org/markup-compatibility/2006" xmlns:p14="http://schemas.microsoft.com/office/powerpoint/2010/main">
+        <mc:Choice Requires="p14">
           <p:contentPart p14:bwMode="auto" r:id="rId15">
             <p14:nvContentPartPr>
               <p14:cNvPr id="20" name="Håndskrift 19">
@@ -5029,7 +5034,7 @@
             </p14:xfrm>
           </p:contentPart>
         </mc:Choice>
-        <mc:Fallback>
+        <mc:Fallback xmlns="">
           <p:pic>
             <p:nvPicPr>
               <p:cNvPr id="20" name="Håndskrift 19">
@@ -5106,7 +5111,12 @@
             <p:ph type="title"/>
           </p:nvPr>
         </p:nvSpPr>
-        <p:spPr/>
+        <p:spPr>
+          <a:xfrm>
+            <a:off x="570570" y="0"/>
+            <a:ext cx="10515600" cy="1325563"/>
+          </a:xfrm>
+        </p:spPr>
         <p:txBody>
           <a:bodyPr/>
           <a:lstStyle/>
@@ -5130,41 +5140,116 @@
           </a:p>
         </p:txBody>
       </p:sp>
-      <p:sp>
-        <p:nvSpPr>
-          <p:cNvPr id="3" name="Plassholder for innhold 2">
-            <a:extLst>
-              <a:ext uri="{FF2B5EF4-FFF2-40B4-BE49-F238E27FC236}">
-                <a16:creationId xmlns:a16="http://schemas.microsoft.com/office/drawing/2014/main" id="{DD3F77A5-DD45-F733-DDA5-E5E8DF8E52F2}"/>
-              </a:ext>
-            </a:extLst>
-          </p:cNvPr>
-          <p:cNvSpPr>
-            <a:spLocks noGrp="1"/>
-          </p:cNvSpPr>
-          <p:nvPr>
-            <p:ph sz="half" idx="1"/>
-          </p:nvPr>
-        </p:nvSpPr>
-        <p:spPr/>
-        <p:txBody>
-          <a:bodyPr/>
-          <a:lstStyle/>
-          <a:p>
-            <a:pPr marL="0" indent="0">
-              <a:buNone/>
-            </a:pPr>
-            <a:r>
-              <a:rPr lang="nb-NO" dirty="0">
-                <a:solidFill>
-                  <a:srgbClr val="FF0000"/>
-                </a:solidFill>
-              </a:rPr>
-              <a:t>Legg inn bilde av topp-nivået her</a:t>
-            </a:r>
-          </a:p>
-        </p:txBody>
-      </p:sp>
+      <p:pic>
+        <p:nvPicPr>
+          <p:cNvPr id="5" name="Bilde 4" descr="Et bilde som inneholder skjermbilde, tekst, diagram, design&#10;&#10;KI-generert innhold kan være feil.">
+            <a:extLst>
+              <a:ext uri="{FF2B5EF4-FFF2-40B4-BE49-F238E27FC236}">
+                <a16:creationId xmlns:a16="http://schemas.microsoft.com/office/drawing/2014/main" id="{EC39C8D0-71F2-7CBB-47D6-166FF279D8C5}"/>
+              </a:ext>
+            </a:extLst>
+          </p:cNvPr>
+          <p:cNvPicPr>
+            <a:picLocks noChangeAspect="1"/>
+          </p:cNvPicPr>
+          <p:nvPr/>
+        </p:nvPicPr>
+        <p:blipFill>
+          <a:blip r:embed="rId3">
+            <a:extLst>
+              <a:ext uri="{28A0092B-C50C-407E-A947-70E740481C1C}">
+                <a14:useLocalDpi xmlns:a14="http://schemas.microsoft.com/office/drawing/2010/main" val="0"/>
+              </a:ext>
+            </a:extLst>
+          </a:blip>
+          <a:stretch>
+            <a:fillRect/>
+          </a:stretch>
+        </p:blipFill>
+        <p:spPr>
+          <a:xfrm>
+            <a:off x="181073" y="1388374"/>
+            <a:ext cx="7661773" cy="4571112"/>
+          </a:xfrm>
+          <a:prstGeom prst="rect">
+            <a:avLst/>
+          </a:prstGeom>
+        </p:spPr>
+      </p:pic>
+      <p:pic>
+        <p:nvPicPr>
+          <p:cNvPr id="7" name="Bilde 6" descr="Et bilde som inneholder skjermbilde, tekst, design&#10;&#10;KI-generert innhold kan være feil.">
+            <a:extLst>
+              <a:ext uri="{FF2B5EF4-FFF2-40B4-BE49-F238E27FC236}">
+                <a16:creationId xmlns:a16="http://schemas.microsoft.com/office/drawing/2014/main" id="{807C0110-FA36-9B16-901E-D92030912EA1}"/>
+              </a:ext>
+            </a:extLst>
+          </p:cNvPr>
+          <p:cNvPicPr>
+            <a:picLocks noChangeAspect="1"/>
+          </p:cNvPicPr>
+          <p:nvPr/>
+        </p:nvPicPr>
+        <p:blipFill>
+          <a:blip r:embed="rId4">
+            <a:extLst>
+              <a:ext uri="{28A0092B-C50C-407E-A947-70E740481C1C}">
+                <a14:useLocalDpi xmlns:a14="http://schemas.microsoft.com/office/drawing/2010/main" val="0"/>
+              </a:ext>
+            </a:extLst>
+          </a:blip>
+          <a:srcRect r="49326"/>
+          <a:stretch>
+            <a:fillRect/>
+          </a:stretch>
+        </p:blipFill>
+        <p:spPr>
+          <a:xfrm>
+            <a:off x="8077201" y="1390879"/>
+            <a:ext cx="3723844" cy="4759692"/>
+          </a:xfrm>
+          <a:prstGeom prst="rect">
+            <a:avLst/>
+          </a:prstGeom>
+        </p:spPr>
+      </p:pic>
+      <p:pic>
+        <p:nvPicPr>
+          <p:cNvPr id="8" name="Bilde 7" descr="Et bilde som inneholder skjermbilde, tekst, design&#10;&#10;KI-generert innhold kan være feil.">
+            <a:extLst>
+              <a:ext uri="{FF2B5EF4-FFF2-40B4-BE49-F238E27FC236}">
+                <a16:creationId xmlns:a16="http://schemas.microsoft.com/office/drawing/2014/main" id="{4FA51EE2-4A44-08E3-D116-DDBC73BD7B4C}"/>
+              </a:ext>
+            </a:extLst>
+          </p:cNvPr>
+          <p:cNvPicPr>
+            <a:picLocks noChangeAspect="1"/>
+          </p:cNvPicPr>
+          <p:nvPr/>
+        </p:nvPicPr>
+        <p:blipFill>
+          <a:blip r:embed="rId4">
+            <a:extLst>
+              <a:ext uri="{28A0092B-C50C-407E-A947-70E740481C1C}">
+                <a14:useLocalDpi xmlns:a14="http://schemas.microsoft.com/office/drawing/2010/main" val="0"/>
+              </a:ext>
+            </a:extLst>
+          </a:blip>
+          <a:srcRect l="61033" t="21237" b="67772"/>
+          <a:stretch>
+            <a:fillRect/>
+          </a:stretch>
+        </p:blipFill>
+        <p:spPr>
+          <a:xfrm>
+            <a:off x="8066312" y="699885"/>
+            <a:ext cx="3723844" cy="680293"/>
+          </a:xfrm>
+          <a:prstGeom prst="rect">
+            <a:avLst/>
+          </a:prstGeom>
+        </p:spPr>
+      </p:pic>
     </p:spTree>
     <p:extLst>
       <p:ext uri="{BB962C8B-B14F-4D97-AF65-F5344CB8AC3E}">
@@ -5211,7 +5296,12 @@
             <p:ph type="title"/>
           </p:nvPr>
         </p:nvSpPr>
-        <p:spPr/>
+        <p:spPr>
+          <a:xfrm>
+            <a:off x="559420" y="0"/>
+            <a:ext cx="10515600" cy="1325563"/>
+          </a:xfrm>
+        </p:spPr>
         <p:txBody>
           <a:bodyPr/>
           <a:lstStyle/>
@@ -5235,44 +5325,78 @@
           </a:p>
         </p:txBody>
       </p:sp>
-      <p:sp>
-        <p:nvSpPr>
-          <p:cNvPr id="3" name="Plassholder for innhold 2">
-            <a:extLst>
-              <a:ext uri="{FF2B5EF4-FFF2-40B4-BE49-F238E27FC236}">
-                <a16:creationId xmlns:a16="http://schemas.microsoft.com/office/drawing/2014/main" id="{8000B408-8083-0D4F-67B6-942636CBDE08}"/>
-              </a:ext>
-            </a:extLst>
-          </p:cNvPr>
-          <p:cNvSpPr>
-            <a:spLocks noGrp="1"/>
-          </p:cNvSpPr>
-          <p:nvPr>
-            <p:ph sz="half" idx="1"/>
-          </p:nvPr>
-        </p:nvSpPr>
-        <p:spPr/>
-        <p:txBody>
-          <a:bodyPr/>
-          <a:lstStyle/>
-          <a:p>
-            <a:endParaRPr lang="nb-NO" dirty="0"/>
-          </a:p>
-          <a:p>
-            <a:pPr marL="0" indent="0">
-              <a:buNone/>
-            </a:pPr>
-            <a:r>
-              <a:rPr lang="nb-NO" dirty="0">
-                <a:solidFill>
-                  <a:srgbClr val="FF0000"/>
-                </a:solidFill>
-              </a:rPr>
-              <a:t>Legg inn bilde av de lavere nivåene her</a:t>
-            </a:r>
-          </a:p>
-        </p:txBody>
-      </p:sp>
+      <p:pic>
+        <p:nvPicPr>
+          <p:cNvPr id="11" name="Bilde 10" descr="Et bilde som inneholder skjermbilde, kvadrat, kunst, design&#10;&#10;KI-generert innhold kan være feil.">
+            <a:extLst>
+              <a:ext uri="{FF2B5EF4-FFF2-40B4-BE49-F238E27FC236}">
+                <a16:creationId xmlns:a16="http://schemas.microsoft.com/office/drawing/2014/main" id="{A77CD42E-5E4F-2FA1-E9D3-BCFD4B723716}"/>
+              </a:ext>
+            </a:extLst>
+          </p:cNvPr>
+          <p:cNvPicPr>
+            <a:picLocks noChangeAspect="1"/>
+          </p:cNvPicPr>
+          <p:nvPr/>
+        </p:nvPicPr>
+        <p:blipFill>
+          <a:blip r:embed="rId2">
+            <a:extLst>
+              <a:ext uri="{28A0092B-C50C-407E-A947-70E740481C1C}">
+                <a14:useLocalDpi xmlns:a14="http://schemas.microsoft.com/office/drawing/2010/main" val="0"/>
+              </a:ext>
+            </a:extLst>
+          </a:blip>
+          <a:stretch>
+            <a:fillRect/>
+          </a:stretch>
+        </p:blipFill>
+        <p:spPr>
+          <a:xfrm>
+            <a:off x="189570" y="1182101"/>
+            <a:ext cx="7302190" cy="3915061"/>
+          </a:xfrm>
+          <a:prstGeom prst="rect">
+            <a:avLst/>
+          </a:prstGeom>
+        </p:spPr>
+      </p:pic>
+      <p:pic>
+        <p:nvPicPr>
+          <p:cNvPr id="13" name="Bilde 12" descr="Et bilde som inneholder skjermbilde, design&#10;&#10;KI-generert innhold kan være feil.">
+            <a:extLst>
+              <a:ext uri="{FF2B5EF4-FFF2-40B4-BE49-F238E27FC236}">
+                <a16:creationId xmlns:a16="http://schemas.microsoft.com/office/drawing/2014/main" id="{C6953A38-5303-5190-C65F-636B8F782453}"/>
+              </a:ext>
+            </a:extLst>
+          </p:cNvPr>
+          <p:cNvPicPr>
+            <a:picLocks noChangeAspect="1"/>
+          </p:cNvPicPr>
+          <p:nvPr/>
+        </p:nvPicPr>
+        <p:blipFill>
+          <a:blip r:embed="rId3">
+            <a:extLst>
+              <a:ext uri="{28A0092B-C50C-407E-A947-70E740481C1C}">
+                <a14:useLocalDpi xmlns:a14="http://schemas.microsoft.com/office/drawing/2010/main" val="0"/>
+              </a:ext>
+            </a:extLst>
+          </a:blip>
+          <a:stretch>
+            <a:fillRect/>
+          </a:stretch>
+        </p:blipFill>
+        <p:spPr>
+          <a:xfrm>
+            <a:off x="7198112" y="2746684"/>
+            <a:ext cx="4804318" cy="3859676"/>
+          </a:xfrm>
+          <a:prstGeom prst="rect">
+            <a:avLst/>
+          </a:prstGeom>
+        </p:spPr>
+      </p:pic>
     </p:spTree>
     <p:extLst>
       <p:ext uri="{BB962C8B-B14F-4D97-AF65-F5344CB8AC3E}">
@@ -5332,72 +5456,182 @@
           </a:p>
         </p:txBody>
       </p:sp>
-      <p:sp>
-        <p:nvSpPr>
-          <p:cNvPr id="3" name="Plassholder for innhold 2">
-            <a:extLst>
-              <a:ext uri="{FF2B5EF4-FFF2-40B4-BE49-F238E27FC236}">
-                <a16:creationId xmlns:a16="http://schemas.microsoft.com/office/drawing/2014/main" id="{C6D7467D-EC00-B9CC-1917-52E73116377C}"/>
-              </a:ext>
-            </a:extLst>
-          </p:cNvPr>
-          <p:cNvSpPr>
-            <a:spLocks noGrp="1"/>
-          </p:cNvSpPr>
-          <p:nvPr>
-            <p:ph sz="half" idx="1"/>
-          </p:nvPr>
-        </p:nvSpPr>
-        <p:spPr/>
-        <p:txBody>
-          <a:bodyPr/>
-          <a:lstStyle/>
-          <a:p>
-            <a:pPr marL="0" indent="0">
-              <a:buNone/>
-            </a:pPr>
-            <a:endParaRPr lang="nb-NO" dirty="0"/>
-          </a:p>
-          <a:p>
-            <a:pPr marL="0" indent="0">
-              <a:buNone/>
-            </a:pPr>
-            <a:r>
-              <a:rPr lang="nb-NO" dirty="0">
-                <a:solidFill>
-                  <a:srgbClr val="FF0000"/>
-                </a:solidFill>
-              </a:rPr>
-              <a:t>Gjør estimat når mikroarkitekturen er ferdig</a:t>
-            </a:r>
-          </a:p>
-        </p:txBody>
-      </p:sp>
-      <p:sp>
-        <p:nvSpPr>
-          <p:cNvPr id="4" name="Plassholder for innhold 3">
-            <a:extLst>
-              <a:ext uri="{FF2B5EF4-FFF2-40B4-BE49-F238E27FC236}">
-                <a16:creationId xmlns:a16="http://schemas.microsoft.com/office/drawing/2014/main" id="{DD6E9CFA-7569-8835-E4E0-9A33CE35AF4B}"/>
-              </a:ext>
-            </a:extLst>
-          </p:cNvPr>
-          <p:cNvSpPr>
-            <a:spLocks noGrp="1"/>
-          </p:cNvSpPr>
-          <p:nvPr>
-            <p:ph sz="half" idx="2"/>
-          </p:nvPr>
-        </p:nvSpPr>
-        <p:spPr/>
-        <p:txBody>
-          <a:bodyPr/>
-          <a:lstStyle/>
-          <a:p>
-            <a:endParaRPr lang="nb-NO" dirty="0"/>
-          </a:p>
-        </p:txBody>
-      </p:sp>
+      <mc:AlternateContent xmlns:mc="http://schemas.openxmlformats.org/markup-compatibility/2006">
+        <mc:Choice xmlns:a14="http://schemas.microsoft.com/office/drawing/2010/main" Requires="a14">
+          <p:sp>
+            <p:nvSpPr>
+              <p:cNvPr id="4" name="Plassholder for innhold 3">
+                <a:extLst>
+                  <a:ext uri="{FF2B5EF4-FFF2-40B4-BE49-F238E27FC236}">
+                    <a16:creationId xmlns:a16="http://schemas.microsoft.com/office/drawing/2014/main" id="{DD6E9CFA-7569-8835-E4E0-9A33CE35AF4B}"/>
+                  </a:ext>
+                </a:extLst>
+              </p:cNvPr>
+              <p:cNvSpPr>
+                <a:spLocks noGrp="1"/>
+              </p:cNvSpPr>
+              <p:nvPr>
+                <p:ph sz="half" idx="2"/>
+              </p:nvPr>
+            </p:nvSpPr>
+            <p:spPr>
+              <a:xfrm>
+                <a:off x="955308" y="1917065"/>
+                <a:ext cx="7134726" cy="4351338"/>
+              </a:xfrm>
+            </p:spPr>
+            <p:txBody>
+              <a:bodyPr/>
+              <a:lstStyle/>
+              <a:p>
+                <a14:m>
+                  <m:oMath xmlns:m="http://schemas.openxmlformats.org/officeDocument/2006/math">
+                    <m:r>
+                      <m:rPr>
+                        <m:sty m:val="p"/>
+                      </m:rPr>
+                      <a:rPr lang="nb-NO" b="0" i="0" smtClean="0">
+                        <a:latin typeface="Cambria Math" panose="02040503050406030204" pitchFamily="18" charset="0"/>
+                      </a:rPr>
+                      <m:t>E</m:t>
+                    </m:r>
+                    <m:r>
+                      <a:rPr lang="nb-NO" i="1" smtClean="0">
+                        <a:latin typeface="Cambria Math" panose="02040503050406030204" pitchFamily="18" charset="0"/>
+                      </a:rPr>
+                      <m:t>=</m:t>
+                    </m:r>
+                    <m:r>
+                      <a:rPr lang="nb-NO" b="0" i="1" smtClean="0">
+                        <a:latin typeface="Cambria Math" panose="02040503050406030204" pitchFamily="18" charset="0"/>
+                      </a:rPr>
+                      <m:t>𝑛</m:t>
+                    </m:r>
+                    <m:r>
+                      <a:rPr lang="nb-NO" b="0" i="1" smtClean="0">
+                        <a:latin typeface="Cambria Math" panose="02040503050406030204" pitchFamily="18" charset="0"/>
+                      </a:rPr>
+                      <m:t> ×</m:t>
+                    </m:r>
+                    <m:d>
+                      <m:dPr>
+                        <m:ctrlPr>
+                          <a:rPr lang="nb-NO" b="0" i="1" smtClean="0">
+                            <a:latin typeface="Cambria Math" panose="02040503050406030204" pitchFamily="18" charset="0"/>
+                            <a:ea typeface="Cambria Math" panose="02040503050406030204" pitchFamily="18" charset="0"/>
+                          </a:rPr>
+                        </m:ctrlPr>
+                      </m:dPr>
+                      <m:e>
+                        <m:r>
+                          <a:rPr lang="nb-NO" b="0" i="1" smtClean="0">
+                            <a:latin typeface="Cambria Math" panose="02040503050406030204" pitchFamily="18" charset="0"/>
+                            <a:ea typeface="Cambria Math" panose="02040503050406030204" pitchFamily="18" charset="0"/>
+                          </a:rPr>
+                          <m:t>2</m:t>
+                        </m:r>
+                        <m:r>
+                          <a:rPr lang="nb-NO" b="0" i="1" smtClean="0">
+                            <a:latin typeface="Cambria Math" panose="02040503050406030204" pitchFamily="18" charset="0"/>
+                            <a:ea typeface="Cambria Math" panose="02040503050406030204" pitchFamily="18" charset="0"/>
+                          </a:rPr>
+                          <m:t>𝑛</m:t>
+                        </m:r>
+                        <m:r>
+                          <a:rPr lang="nb-NO" b="0" i="1" smtClean="0">
+                            <a:latin typeface="Cambria Math" panose="02040503050406030204" pitchFamily="18" charset="0"/>
+                            <a:ea typeface="Cambria Math" panose="02040503050406030204" pitchFamily="18" charset="0"/>
+                          </a:rPr>
+                          <m:t>+1</m:t>
+                        </m:r>
+                      </m:e>
+                    </m:d>
+                    <m:r>
+                      <a:rPr lang="nb-NO" b="0" i="1" smtClean="0">
+                        <a:latin typeface="Cambria Math" panose="02040503050406030204" pitchFamily="18" charset="0"/>
+                        <a:ea typeface="Cambria Math" panose="02040503050406030204" pitchFamily="18" charset="0"/>
+                      </a:rPr>
+                      <m:t>+1=131 329 </m:t>
+                    </m:r>
+                    <m:r>
+                      <a:rPr lang="nb-NO" b="0" i="1" smtClean="0">
+                        <a:latin typeface="Cambria Math" panose="02040503050406030204" pitchFamily="18" charset="0"/>
+                        <a:ea typeface="Cambria Math" panose="02040503050406030204" pitchFamily="18" charset="0"/>
+                      </a:rPr>
+                      <m:t>𝑐𝑦𝑐𝑙𝑒𝑠</m:t>
+                    </m:r>
+                  </m:oMath>
+                </a14:m>
+                <a:endParaRPr lang="nb-NO" b="0" dirty="0">
+                  <a:ea typeface="Cambria Math" panose="02040503050406030204" pitchFamily="18" charset="0"/>
+                </a:endParaRPr>
+              </a:p>
+              <a:p>
+                <a14:m>
+                  <m:oMath xmlns:m="http://schemas.openxmlformats.org/officeDocument/2006/math">
+                    <m:r>
+                      <a:rPr lang="nb-NO" b="0" i="1" smtClean="0">
+                        <a:latin typeface="Cambria Math" panose="02040503050406030204" pitchFamily="18" charset="0"/>
+                      </a:rPr>
+                      <m:t>𝑛</m:t>
+                    </m:r>
+                    <m:r>
+                      <a:rPr lang="nb-NO" b="0" i="1" smtClean="0">
+                        <a:latin typeface="Cambria Math" panose="02040503050406030204" pitchFamily="18" charset="0"/>
+                      </a:rPr>
+                      <m:t>=256</m:t>
+                    </m:r>
+                  </m:oMath>
+                </a14:m>
+                <a:endParaRPr lang="nb-NO" dirty="0"/>
+              </a:p>
+            </p:txBody>
+          </p:sp>
+        </mc:Choice>
+        <mc:Fallback>
+          <p:sp>
+            <p:nvSpPr>
+              <p:cNvPr id="4" name="Plassholder for innhold 3">
+                <a:extLst>
+                  <a:ext uri="{FF2B5EF4-FFF2-40B4-BE49-F238E27FC236}">
+                    <a16:creationId xmlns:a16="http://schemas.microsoft.com/office/drawing/2014/main" id="{DD6E9CFA-7569-8835-E4E0-9A33CE35AF4B}"/>
+                  </a:ext>
+                </a:extLst>
+              </p:cNvPr>
+              <p:cNvSpPr>
+                <a:spLocks noGrp="1" noRot="1" noChangeAspect="1" noMove="1" noResize="1" noEditPoints="1" noAdjustHandles="1" noChangeArrowheads="1" noChangeShapeType="1" noTextEdit="1"/>
+              </p:cNvSpPr>
+              <p:nvPr>
+                <p:ph sz="half" idx="2"/>
+              </p:nvPr>
+            </p:nvSpPr>
+            <p:spPr>
+              <a:xfrm>
+                <a:off x="955308" y="1917065"/>
+                <a:ext cx="7134726" cy="4351338"/>
+              </a:xfrm>
+              <a:blipFill>
+                <a:blip r:embed="rId2"/>
+                <a:stretch>
+                  <a:fillRect/>
+                </a:stretch>
+              </a:blipFill>
+            </p:spPr>
+            <p:txBody>
+              <a:bodyPr/>
+              <a:lstStyle/>
+              <a:p>
+                <a:r>
+                  <a:rPr lang="nb-NO">
+                    <a:noFill/>
+                  </a:rPr>
+                  <a:t> </a:t>
+                </a:r>
+              </a:p>
+            </p:txBody>
+          </p:sp>
+        </mc:Fallback>
+      </mc:AlternateContent>
     </p:spTree>
     <p:extLst>
       <p:ext uri="{BB962C8B-B14F-4D97-AF65-F5344CB8AC3E}">

</xml_diff>

<commit_message>
fixes to microarcitecture, figures and ppt
</commit_message>
<xml_diff>
--- a/TermProject/Microarchitecture_presentation.pptx
+++ b/TermProject/Microarchitecture_presentation.pptx
@@ -369,7 +369,7 @@
           <a:p>
             <a:fld id="{F4BB8A02-1B8F-4CA0-82C6-CD71F4E181AC}" type="datetimeFigureOut">
               <a:rPr lang="nb-NO" smtClean="0"/>
-              <a:t>29.09.2025</a:t>
+              <a:t>01.10.2025</a:t>
             </a:fld>
             <a:endParaRPr lang="nb-NO"/>
           </a:p>
@@ -1412,7 +1412,7 @@
           <a:p>
             <a:fld id="{AB450C0E-87F3-42F7-9C88-607322746BDD}" type="datetimeFigureOut">
               <a:rPr lang="nb-NO" smtClean="0"/>
-              <a:t>29.09.2025</a:t>
+              <a:t>01.10.2025</a:t>
             </a:fld>
             <a:endParaRPr lang="nb-NO"/>
           </a:p>
@@ -1610,7 +1610,7 @@
           <a:p>
             <a:fld id="{AB450C0E-87F3-42F7-9C88-607322746BDD}" type="datetimeFigureOut">
               <a:rPr lang="nb-NO" smtClean="0"/>
-              <a:t>29.09.2025</a:t>
+              <a:t>01.10.2025</a:t>
             </a:fld>
             <a:endParaRPr lang="nb-NO"/>
           </a:p>
@@ -1818,7 +1818,7 @@
           <a:p>
             <a:fld id="{AB450C0E-87F3-42F7-9C88-607322746BDD}" type="datetimeFigureOut">
               <a:rPr lang="nb-NO" smtClean="0"/>
-              <a:t>29.09.2025</a:t>
+              <a:t>01.10.2025</a:t>
             </a:fld>
             <a:endParaRPr lang="nb-NO"/>
           </a:p>
@@ -2016,7 +2016,7 @@
           <a:p>
             <a:fld id="{AB450C0E-87F3-42F7-9C88-607322746BDD}" type="datetimeFigureOut">
               <a:rPr lang="nb-NO" smtClean="0"/>
-              <a:t>29.09.2025</a:t>
+              <a:t>01.10.2025</a:t>
             </a:fld>
             <a:endParaRPr lang="nb-NO"/>
           </a:p>
@@ -2291,7 +2291,7 @@
           <a:p>
             <a:fld id="{AB450C0E-87F3-42F7-9C88-607322746BDD}" type="datetimeFigureOut">
               <a:rPr lang="nb-NO" smtClean="0"/>
-              <a:t>29.09.2025</a:t>
+              <a:t>01.10.2025</a:t>
             </a:fld>
             <a:endParaRPr lang="nb-NO"/>
           </a:p>
@@ -2556,7 +2556,7 @@
           <a:p>
             <a:fld id="{AB450C0E-87F3-42F7-9C88-607322746BDD}" type="datetimeFigureOut">
               <a:rPr lang="nb-NO" smtClean="0"/>
-              <a:t>29.09.2025</a:t>
+              <a:t>01.10.2025</a:t>
             </a:fld>
             <a:endParaRPr lang="nb-NO"/>
           </a:p>
@@ -2968,7 +2968,7 @@
           <a:p>
             <a:fld id="{AB450C0E-87F3-42F7-9C88-607322746BDD}" type="datetimeFigureOut">
               <a:rPr lang="nb-NO" smtClean="0"/>
-              <a:t>29.09.2025</a:t>
+              <a:t>01.10.2025</a:t>
             </a:fld>
             <a:endParaRPr lang="nb-NO"/>
           </a:p>
@@ -3109,7 +3109,7 @@
           <a:p>
             <a:fld id="{AB450C0E-87F3-42F7-9C88-607322746BDD}" type="datetimeFigureOut">
               <a:rPr lang="nb-NO" smtClean="0"/>
-              <a:t>29.09.2025</a:t>
+              <a:t>01.10.2025</a:t>
             </a:fld>
             <a:endParaRPr lang="nb-NO"/>
           </a:p>
@@ -3222,7 +3222,7 @@
           <a:p>
             <a:fld id="{AB450C0E-87F3-42F7-9C88-607322746BDD}" type="datetimeFigureOut">
               <a:rPr lang="nb-NO" smtClean="0"/>
-              <a:t>29.09.2025</a:t>
+              <a:t>01.10.2025</a:t>
             </a:fld>
             <a:endParaRPr lang="nb-NO"/>
           </a:p>
@@ -3533,7 +3533,7 @@
           <a:p>
             <a:fld id="{AB450C0E-87F3-42F7-9C88-607322746BDD}" type="datetimeFigureOut">
               <a:rPr lang="nb-NO" smtClean="0"/>
-              <a:t>29.09.2025</a:t>
+              <a:t>01.10.2025</a:t>
             </a:fld>
             <a:endParaRPr lang="nb-NO"/>
           </a:p>
@@ -3821,7 +3821,7 @@
           <a:p>
             <a:fld id="{AB450C0E-87F3-42F7-9C88-607322746BDD}" type="datetimeFigureOut">
               <a:rPr lang="nb-NO" smtClean="0"/>
-              <a:t>29.09.2025</a:t>
+              <a:t>01.10.2025</a:t>
             </a:fld>
             <a:endParaRPr lang="nb-NO"/>
           </a:p>
@@ -4062,7 +4062,7 @@
           <a:p>
             <a:fld id="{AB450C0E-87F3-42F7-9C88-607322746BDD}" type="datetimeFigureOut">
               <a:rPr lang="nb-NO" smtClean="0"/>
-              <a:t>29.09.2025</a:t>
+              <a:t>01.10.2025</a:t>
             </a:fld>
             <a:endParaRPr lang="nb-NO"/>
           </a:p>
@@ -5142,10 +5142,10 @@
       </p:sp>
       <p:pic>
         <p:nvPicPr>
-          <p:cNvPr id="5" name="Bilde 4" descr="Et bilde som inneholder skjermbilde, tekst, diagram, design&#10;&#10;KI-generert innhold kan være feil.">
-            <a:extLst>
-              <a:ext uri="{FF2B5EF4-FFF2-40B4-BE49-F238E27FC236}">
-                <a16:creationId xmlns:a16="http://schemas.microsoft.com/office/drawing/2014/main" id="{EC39C8D0-71F2-7CBB-47D6-166FF279D8C5}"/>
+          <p:cNvPr id="8" name="Bilde 7" descr="Et bilde som inneholder skjermbilde, tekst, design&#10;&#10;KI-generert innhold kan være feil.">
+            <a:extLst>
+              <a:ext uri="{FF2B5EF4-FFF2-40B4-BE49-F238E27FC236}">
+                <a16:creationId xmlns:a16="http://schemas.microsoft.com/office/drawing/2014/main" id="{4FA51EE2-4A44-08E3-D116-DDBC73BD7B4C}"/>
               </a:ext>
             </a:extLst>
           </p:cNvPr>
@@ -5156,79 +5156,6 @@
         </p:nvPicPr>
         <p:blipFill>
           <a:blip r:embed="rId3">
-            <a:extLst>
-              <a:ext uri="{28A0092B-C50C-407E-A947-70E740481C1C}">
-                <a14:useLocalDpi xmlns:a14="http://schemas.microsoft.com/office/drawing/2010/main" val="0"/>
-              </a:ext>
-            </a:extLst>
-          </a:blip>
-          <a:stretch>
-            <a:fillRect/>
-          </a:stretch>
-        </p:blipFill>
-        <p:spPr>
-          <a:xfrm>
-            <a:off x="181073" y="1388374"/>
-            <a:ext cx="7661773" cy="4571112"/>
-          </a:xfrm>
-          <a:prstGeom prst="rect">
-            <a:avLst/>
-          </a:prstGeom>
-        </p:spPr>
-      </p:pic>
-      <p:pic>
-        <p:nvPicPr>
-          <p:cNvPr id="7" name="Bilde 6" descr="Et bilde som inneholder skjermbilde, tekst, design&#10;&#10;KI-generert innhold kan være feil.">
-            <a:extLst>
-              <a:ext uri="{FF2B5EF4-FFF2-40B4-BE49-F238E27FC236}">
-                <a16:creationId xmlns:a16="http://schemas.microsoft.com/office/drawing/2014/main" id="{807C0110-FA36-9B16-901E-D92030912EA1}"/>
-              </a:ext>
-            </a:extLst>
-          </p:cNvPr>
-          <p:cNvPicPr>
-            <a:picLocks noChangeAspect="1"/>
-          </p:cNvPicPr>
-          <p:nvPr/>
-        </p:nvPicPr>
-        <p:blipFill>
-          <a:blip r:embed="rId4">
-            <a:extLst>
-              <a:ext uri="{28A0092B-C50C-407E-A947-70E740481C1C}">
-                <a14:useLocalDpi xmlns:a14="http://schemas.microsoft.com/office/drawing/2010/main" val="0"/>
-              </a:ext>
-            </a:extLst>
-          </a:blip>
-          <a:srcRect r="49326"/>
-          <a:stretch>
-            <a:fillRect/>
-          </a:stretch>
-        </p:blipFill>
-        <p:spPr>
-          <a:xfrm>
-            <a:off x="8077201" y="1390879"/>
-            <a:ext cx="3723844" cy="4759692"/>
-          </a:xfrm>
-          <a:prstGeom prst="rect">
-            <a:avLst/>
-          </a:prstGeom>
-        </p:spPr>
-      </p:pic>
-      <p:pic>
-        <p:nvPicPr>
-          <p:cNvPr id="8" name="Bilde 7" descr="Et bilde som inneholder skjermbilde, tekst, design&#10;&#10;KI-generert innhold kan være feil.">
-            <a:extLst>
-              <a:ext uri="{FF2B5EF4-FFF2-40B4-BE49-F238E27FC236}">
-                <a16:creationId xmlns:a16="http://schemas.microsoft.com/office/drawing/2014/main" id="{4FA51EE2-4A44-08E3-D116-DDBC73BD7B4C}"/>
-              </a:ext>
-            </a:extLst>
-          </p:cNvPr>
-          <p:cNvPicPr>
-            <a:picLocks noChangeAspect="1"/>
-          </p:cNvPicPr>
-          <p:nvPr/>
-        </p:nvPicPr>
-        <p:blipFill>
-          <a:blip r:embed="rId4">
             <a:extLst>
               <a:ext uri="{28A0092B-C50C-407E-A947-70E740481C1C}">
                 <a14:useLocalDpi xmlns:a14="http://schemas.microsoft.com/office/drawing/2010/main" val="0"/>
@@ -5244,6 +5171,110 @@
           <a:xfrm>
             <a:off x="8066312" y="699885"/>
             <a:ext cx="3723844" cy="680293"/>
+          </a:xfrm>
+          <a:prstGeom prst="rect">
+            <a:avLst/>
+          </a:prstGeom>
+        </p:spPr>
+      </p:pic>
+      <p:pic>
+        <p:nvPicPr>
+          <p:cNvPr id="4" name="Bilde 3" descr="Et bilde som inneholder skjermbilde, diagram, design&#10;&#10;KI-generert innhold kan være feil.">
+            <a:extLst>
+              <a:ext uri="{FF2B5EF4-FFF2-40B4-BE49-F238E27FC236}">
+                <a16:creationId xmlns:a16="http://schemas.microsoft.com/office/drawing/2014/main" id="{37D7A7EC-2DE8-EFBE-42EB-EAA518FFB626}"/>
+              </a:ext>
+            </a:extLst>
+          </p:cNvPr>
+          <p:cNvPicPr>
+            <a:picLocks noChangeAspect="1"/>
+          </p:cNvPicPr>
+          <p:nvPr/>
+        </p:nvPicPr>
+        <p:blipFill>
+          <a:blip r:embed="rId4">
+            <a:extLst>
+              <a:ext uri="{28A0092B-C50C-407E-A947-70E740481C1C}">
+                <a14:useLocalDpi xmlns:a14="http://schemas.microsoft.com/office/drawing/2010/main" val="0"/>
+              </a:ext>
+            </a:extLst>
+          </a:blip>
+          <a:srcRect t="28643" r="32898"/>
+          <a:stretch>
+            <a:fillRect/>
+          </a:stretch>
+        </p:blipFill>
+        <p:spPr>
+          <a:xfrm>
+            <a:off x="157446" y="1040031"/>
+            <a:ext cx="8766193" cy="4543259"/>
+          </a:xfrm>
+          <a:prstGeom prst="rect">
+            <a:avLst/>
+          </a:prstGeom>
+        </p:spPr>
+      </p:pic>
+      <p:pic>
+        <p:nvPicPr>
+          <p:cNvPr id="9" name="Bilde 8" descr="Et bilde som inneholder skjermbilde, tekst, design&#10;&#10;KI-generert innhold kan være feil.">
+            <a:extLst>
+              <a:ext uri="{FF2B5EF4-FFF2-40B4-BE49-F238E27FC236}">
+                <a16:creationId xmlns:a16="http://schemas.microsoft.com/office/drawing/2014/main" id="{E558B31E-E145-A4CF-0AA4-E987F5FDF699}"/>
+              </a:ext>
+            </a:extLst>
+          </p:cNvPr>
+          <p:cNvPicPr>
+            <a:picLocks noChangeAspect="1"/>
+          </p:cNvPicPr>
+          <p:nvPr/>
+        </p:nvPicPr>
+        <p:blipFill>
+          <a:blip r:embed="rId5">
+            <a:extLst>
+              <a:ext uri="{28A0092B-C50C-407E-A947-70E740481C1C}">
+                <a14:useLocalDpi xmlns:a14="http://schemas.microsoft.com/office/drawing/2010/main" val="0"/>
+              </a:ext>
+            </a:extLst>
+          </a:blip>
+          <a:srcRect r="50850"/>
+          <a:stretch>
+            <a:fillRect/>
+          </a:stretch>
+        </p:blipFill>
+        <p:spPr>
+          <a:xfrm>
+            <a:off x="8560354" y="1614695"/>
+            <a:ext cx="3229802" cy="4256237"/>
+          </a:xfrm>
+          <a:prstGeom prst="rect">
+            <a:avLst/>
+          </a:prstGeom>
+        </p:spPr>
+      </p:pic>
+      <p:pic>
+        <p:nvPicPr>
+          <p:cNvPr id="11" name="Bilde 10">
+            <a:extLst>
+              <a:ext uri="{FF2B5EF4-FFF2-40B4-BE49-F238E27FC236}">
+                <a16:creationId xmlns:a16="http://schemas.microsoft.com/office/drawing/2014/main" id="{0CE35CF2-804B-4EE6-B407-159EFBBF1775}"/>
+              </a:ext>
+            </a:extLst>
+          </p:cNvPr>
+          <p:cNvPicPr>
+            <a:picLocks noChangeAspect="1"/>
+          </p:cNvPicPr>
+          <p:nvPr/>
+        </p:nvPicPr>
+        <p:blipFill>
+          <a:blip r:embed="rId6"/>
+          <a:stretch>
+            <a:fillRect/>
+          </a:stretch>
+        </p:blipFill>
+        <p:spPr>
+          <a:xfrm>
+            <a:off x="6378360" y="5331103"/>
+            <a:ext cx="2545279" cy="1292218"/>
           </a:xfrm>
           <a:prstGeom prst="rect">
             <a:avLst/>
@@ -5327,10 +5358,10 @@
       </p:sp>
       <p:pic>
         <p:nvPicPr>
-          <p:cNvPr id="11" name="Bilde 10" descr="Et bilde som inneholder skjermbilde, kvadrat, kunst, design&#10;&#10;KI-generert innhold kan være feil.">
-            <a:extLst>
-              <a:ext uri="{FF2B5EF4-FFF2-40B4-BE49-F238E27FC236}">
-                <a16:creationId xmlns:a16="http://schemas.microsoft.com/office/drawing/2014/main" id="{A77CD42E-5E4F-2FA1-E9D3-BCFD4B723716}"/>
+          <p:cNvPr id="4" name="Bilde 3" descr="Et bilde som inneholder skjermbilde, design&#10;&#10;KI-generert innhold kan være feil.">
+            <a:extLst>
+              <a:ext uri="{FF2B5EF4-FFF2-40B4-BE49-F238E27FC236}">
+                <a16:creationId xmlns:a16="http://schemas.microsoft.com/office/drawing/2014/main" id="{35257B68-6B0F-A849-BB0F-281712B4EF18}"/>
               </a:ext>
             </a:extLst>
           </p:cNvPr>
@@ -5347,14 +5378,15 @@
               </a:ext>
             </a:extLst>
           </a:blip>
+          <a:srcRect l="16786" b="20604"/>
           <a:stretch>
             <a:fillRect/>
           </a:stretch>
         </p:blipFill>
         <p:spPr>
           <a:xfrm>
-            <a:off x="189570" y="1182101"/>
-            <a:ext cx="7302190" cy="3915061"/>
+            <a:off x="8325795" y="360814"/>
+            <a:ext cx="3585106" cy="4143201"/>
           </a:xfrm>
           <a:prstGeom prst="rect">
             <a:avLst/>
@@ -5363,10 +5395,10 @@
       </p:pic>
       <p:pic>
         <p:nvPicPr>
-          <p:cNvPr id="13" name="Bilde 12" descr="Et bilde som inneholder skjermbilde, design&#10;&#10;KI-generert innhold kan være feil.">
-            <a:extLst>
-              <a:ext uri="{FF2B5EF4-FFF2-40B4-BE49-F238E27FC236}">
-                <a16:creationId xmlns:a16="http://schemas.microsoft.com/office/drawing/2014/main" id="{C6953A38-5303-5190-C65F-636B8F782453}"/>
+          <p:cNvPr id="6" name="Bilde 5">
+            <a:extLst>
+              <a:ext uri="{FF2B5EF4-FFF2-40B4-BE49-F238E27FC236}">
+                <a16:creationId xmlns:a16="http://schemas.microsoft.com/office/drawing/2014/main" id="{8F2FC3AD-6116-B478-5AC6-3071AC7D6B00}"/>
               </a:ext>
             </a:extLst>
           </p:cNvPr>
@@ -5376,21 +5408,15 @@
           <p:nvPr/>
         </p:nvPicPr>
         <p:blipFill>
-          <a:blip r:embed="rId3">
-            <a:extLst>
-              <a:ext uri="{28A0092B-C50C-407E-A947-70E740481C1C}">
-                <a14:useLocalDpi xmlns:a14="http://schemas.microsoft.com/office/drawing/2010/main" val="0"/>
-              </a:ext>
-            </a:extLst>
-          </a:blip>
+          <a:blip r:embed="rId3"/>
           <a:stretch>
             <a:fillRect/>
           </a:stretch>
         </p:blipFill>
         <p:spPr>
           <a:xfrm>
-            <a:off x="7198112" y="2746684"/>
-            <a:ext cx="4804318" cy="3859676"/>
+            <a:off x="9483507" y="4637837"/>
+            <a:ext cx="2708493" cy="2283631"/>
           </a:xfrm>
           <a:prstGeom prst="rect">
             <a:avLst/>
@@ -5528,13 +5554,6 @@
                             <a:latin typeface="Cambria Math" panose="02040503050406030204" pitchFamily="18" charset="0"/>
                             <a:ea typeface="Cambria Math" panose="02040503050406030204" pitchFamily="18" charset="0"/>
                           </a:rPr>
-                          <m:t>2</m:t>
-                        </m:r>
-                        <m:r>
-                          <a:rPr lang="nb-NO" b="0" i="1" smtClean="0">
-                            <a:latin typeface="Cambria Math" panose="02040503050406030204" pitchFamily="18" charset="0"/>
-                            <a:ea typeface="Cambria Math" panose="02040503050406030204" pitchFamily="18" charset="0"/>
-                          </a:rPr>
                           <m:t>𝑛</m:t>
                         </m:r>
                         <m:r>
@@ -5551,7 +5570,14 @@
                         <a:latin typeface="Cambria Math" panose="02040503050406030204" pitchFamily="18" charset="0"/>
                         <a:ea typeface="Cambria Math" panose="02040503050406030204" pitchFamily="18" charset="0"/>
                       </a:rPr>
-                      <m:t>+1=131 329 </m:t>
+                      <m:t>+1=</m:t>
+                    </m:r>
+                    <m:r>
+                      <a:rPr lang="nb-NO" b="0" i="1" smtClean="0">
+                        <a:latin typeface="Cambria Math" panose="02040503050406030204" pitchFamily="18" charset="0"/>
+                        <a:ea typeface="Cambria Math" panose="02040503050406030204" pitchFamily="18" charset="0"/>
+                      </a:rPr>
+                      <m:t>65 793 </m:t>
                     </m:r>
                     <m:r>
                       <a:rPr lang="nb-NO" b="0" i="1" smtClean="0">

</xml_diff>